<commit_message>
fix(act): correct the order year, describe the act as based on form R-1, drop a made-up standard; align the deck and pitch script with verified facts
Co-Authored-By: Claude Opus 5.5 <noreply@anthropic.com>
</commit_message>
<xml_diff>
--- a/docs/SteppeInvoice_Presentation.pptx
+++ b/docs/SteppeInvoice_Presentation.pptx
@@ -4,6 +4,9 @@
   <p:sldMasterIdLst>
     <p:sldMasterId id="2147483648" r:id="rId1"/>
   </p:sldMasterIdLst>
+  <p:notesMasterIdLst>
+    <p:notesMasterId r:id="rId15"/>
+  </p:notesMasterIdLst>
   <p:sldIdLst>
     <p:sldId id="256" r:id="rId2"/>
     <p:sldId id="257" r:id="rId3"/>
@@ -19,9 +22,6 @@
     <p:sldId id="267" r:id="rId13"/>
     <p:sldId id="268" r:id="rId14"/>
   </p:sldIdLst>
-  <p:notesMasterIdLst>
-    <p:notesMasterId r:id="rId15"/>
-  </p:notesMasterIdLst>
   <p:sldSz cx="12192000" cy="6858000"/>
   <p:notesSz cx="6858000" cy="12192000"/>
   <p:defaultTextStyle>
@@ -119,19 +119,19 @@
   <p:extLst>
     <p:ext uri="{521415D9-36F7-43E2-AB2F-B90AF26B5E84}">
       <p14:sectionLst xmlns:p14="http://schemas.microsoft.com/office/powerpoint/2010/main">
-        <p14:section name="Старт" id="{5abc5101-c9c9-206c-fad0-55a144c2e208}">
+        <p14:section name="Старт" id="{5ABC5101-C9C9-206C-FAD0-55A144C2E208}">
           <p14:sldIdLst>
             <p14:sldId id="256"/>
             <p14:sldId id="257"/>
           </p14:sldIdLst>
         </p14:section>
-        <p14:section name="Проблема" id="{77cbc6f1-f56f-383e-eb4c-7494b049f9ab}">
+        <p14:section name="Проблема" id="{77CBC6F1-F56F-383E-EB4C-7494B049F9AB}">
           <p14:sldIdLst>
             <p14:sldId id="258"/>
             <p14:sldId id="259"/>
           </p14:sldIdLst>
         </p14:section>
-        <p14:section name="Решение" id="{b5793d45-670b-1e7c-bd19-c730f7ebf643}">
+        <p14:section name="Решение" id="{B5793D45-670B-1E7C-BD19-C730F7EBF643}">
           <p14:sldIdLst>
             <p14:sldId id="260"/>
             <p14:sldId id="261"/>
@@ -140,13 +140,13 @@
             <p14:sldId id="264"/>
           </p14:sldIdLst>
         </p14:section>
-        <p14:section name="Бизнес" id="{028f6438-0b3c-8da4-28d0-ec6687f15a33}">
+        <p14:section name="Бизнес" id="{028F6438-0B3C-8DA4-28D0-EC6687F15A33}">
           <p14:sldIdLst>
             <p14:sldId id="265"/>
             <p14:sldId id="266"/>
           </p14:sldIdLst>
         </p14:section>
-        <p14:section name="Итог" id="{746cbe77-58c5-ad6a-8b5c-9da2755367b2}">
+        <p14:section name="Итог" id="{746CBE77-58C5-AD6A-8B5C-9DA2755367B2}">
           <p14:sldIdLst>
             <p14:sldId id="267"/>
             <p14:sldId id="268"/>
@@ -183,234 +183,10 @@
           <a:chExt cx="0" cy="0"/>
         </a:xfrm>
       </p:grpSpPr>
-      <p:sp>
-        <p:nvSpPr>
-          <p:cNvPr id="2" name="Header Placeholder 1"/>
-          <p:cNvSpPr>
-            <a:spLocks noGrp="1"/>
-          </p:cNvSpPr>
-          <p:nvPr>
-            <p:ph type="hdr" sz="quarter"/>
-          </p:nvPr>
-        </p:nvSpPr>
-        <p:spPr>
-          <a:xfrm>
-            <a:off x="0" y="0"/>
-            <a:ext cx="2971800" cy="458788"/>
-          </a:xfrm>
-          <a:prstGeom prst="rect">
-            <a:avLst/>
-          </a:prstGeom>
-        </p:spPr>
-        <p:txBody>
-          <a:bodyPr vert="horz" lIns="91440" tIns="45720" rIns="91440" bIns="45720" rtlCol="0"/>
-          <a:lstStyle>
-            <a:lvl1pPr algn="l">
-              <a:defRPr sz="1200"/>
-            </a:lvl1pPr>
-          </a:lstStyle>
-          <a:p>
-            <a:endParaRPr lang="en-US"/>
-          </a:p>
-        </p:txBody>
-      </p:sp>
-      <p:sp>
-        <p:nvSpPr>
-          <p:cNvPr id="3" name="Date Placeholder 2"/>
-          <p:cNvSpPr>
-            <a:spLocks noGrp="1"/>
-          </p:cNvSpPr>
-          <p:nvPr>
-            <p:ph type="dt" idx="1"/>
-          </p:nvPr>
-        </p:nvSpPr>
-        <p:spPr>
-          <a:xfrm>
-            <a:off x="3884613" y="0"/>
-            <a:ext cx="2971800" cy="458788"/>
-          </a:xfrm>
-          <a:prstGeom prst="rect">
-            <a:avLst/>
-          </a:prstGeom>
-        </p:spPr>
-        <p:txBody>
-          <a:bodyPr vert="horz" lIns="91440" tIns="45720" rIns="91440" bIns="45720" rtlCol="0"/>
-          <a:lstStyle>
-            <a:lvl1pPr algn="r">
-              <a:defRPr sz="1200"/>
-            </a:lvl1pPr>
-          </a:lstStyle>
-          <a:p>
-            <a:fld id="{5282F153-3F37-0F45-9E97-73ACFA13230C}" type="datetimeFigureOut">
-              <a:rPr lang="en-US"/>
-              <a:t>7/23/19</a:t>
-            </a:fld>
-            <a:endParaRPr lang="en-US"/>
-          </a:p>
-        </p:txBody>
-      </p:sp>
-      <p:sp>
-        <p:nvSpPr>
-          <p:cNvPr id="4" name="Slide Image Placeholder 3"/>
-          <p:cNvSpPr>
-            <a:spLocks noGrp="1" noRot="1" noChangeAspect="1"/>
-          </p:cNvSpPr>
-          <p:nvPr>
-            <p:ph type="sldImg" idx="2"/>
-          </p:nvPr>
-        </p:nvSpPr>
-        <p:spPr>
-          <a:xfrm>
-            <a:off x="685800" y="1143000"/>
-            <a:ext cx="5486400" cy="3086100"/>
-          </a:xfrm>
-          <a:prstGeom prst="rect">
-            <a:avLst/>
-          </a:prstGeom>
-          <a:noFill/>
-          <a:ln w="12700">
-            <a:solidFill>
-              <a:prstClr val="black"/>
-            </a:solidFill>
-          </a:ln>
-        </p:spPr>
-        <p:txBody>
-          <a:bodyPr vert="horz" lIns="91440" tIns="45720" rIns="91440" bIns="45720" rtlCol="0" anchor="ctr"/>
-          <a:lstStyle/>
-          <a:p>
-            <a:endParaRPr lang="en-US"/>
-          </a:p>
-        </p:txBody>
-      </p:sp>
-      <p:sp>
-        <p:nvSpPr>
-          <p:cNvPr id="5" name="Notes Placeholder 4"/>
-          <p:cNvSpPr>
-            <a:spLocks noGrp="1"/>
-          </p:cNvSpPr>
-          <p:nvPr>
-            <p:ph type="body" sz="quarter" idx="3"/>
-          </p:nvPr>
-        </p:nvSpPr>
-        <p:spPr>
-          <a:xfrm>
-            <a:off x="685800" y="4400550"/>
-            <a:ext cx="5486400" cy="3600450"/>
-          </a:xfrm>
-          <a:prstGeom prst="rect">
-            <a:avLst/>
-          </a:prstGeom>
-        </p:spPr>
-        <p:txBody>
-          <a:bodyPr vert="horz" lIns="91440" tIns="45720" rIns="91440" bIns="45720" rtlCol="0"/>
-          <a:lstStyle/>
-          <a:p>
-            <a:pPr lvl="0"/>
-            <a:r>
-              <a:rPr lang="en-US"/>
-              <a:t>Click to edit Master text styles</a:t>
-            </a:r>
-          </a:p>
-          <a:p>
-            <a:pPr lvl="1"/>
-            <a:r>
-              <a:rPr lang="en-US"/>
-              <a:t>Second level</a:t>
-            </a:r>
-          </a:p>
-          <a:p>
-            <a:pPr lvl="2"/>
-            <a:r>
-              <a:rPr lang="en-US"/>
-              <a:t>Third level</a:t>
-            </a:r>
-          </a:p>
-          <a:p>
-            <a:pPr lvl="3"/>
-            <a:r>
-              <a:rPr lang="en-US"/>
-              <a:t>Fourth level</a:t>
-            </a:r>
-          </a:p>
-          <a:p>
-            <a:pPr lvl="4"/>
-            <a:r>
-              <a:rPr lang="en-US"/>
-              <a:t>Fifth level</a:t>
-            </a:r>
-          </a:p>
-        </p:txBody>
-      </p:sp>
-      <p:sp>
-        <p:nvSpPr>
-          <p:cNvPr id="6" name="Footer Placeholder 5"/>
-          <p:cNvSpPr>
-            <a:spLocks noGrp="1"/>
-          </p:cNvSpPr>
-          <p:nvPr>
-            <p:ph type="ftr" sz="quarter" idx="4"/>
-          </p:nvPr>
-        </p:nvSpPr>
-        <p:spPr>
-          <a:xfrm>
-            <a:off x="0" y="8685213"/>
-            <a:ext cx="2971800" cy="458787"/>
-          </a:xfrm>
-          <a:prstGeom prst="rect">
-            <a:avLst/>
-          </a:prstGeom>
-        </p:spPr>
-        <p:txBody>
-          <a:bodyPr vert="horz" lIns="91440" tIns="45720" rIns="91440" bIns="45720" rtlCol="0" anchor="b"/>
-          <a:lstStyle>
-            <a:lvl1pPr algn="l">
-              <a:defRPr sz="1200"/>
-            </a:lvl1pPr>
-          </a:lstStyle>
-          <a:p>
-            <a:endParaRPr lang="en-US"/>
-          </a:p>
-        </p:txBody>
-      </p:sp>
-      <p:sp>
-        <p:nvSpPr>
-          <p:cNvPr id="7" name="Slide Number Placeholder 6"/>
-          <p:cNvSpPr>
-            <a:spLocks noGrp="1"/>
-          </p:cNvSpPr>
-          <p:nvPr>
-            <p:ph type="sldNum" sz="quarter" idx="5"/>
-          </p:nvPr>
-        </p:nvSpPr>
-        <p:spPr>
-          <a:xfrm>
-            <a:off x="3884613" y="8685213"/>
-            <a:ext cx="2971800" cy="458787"/>
-          </a:xfrm>
-          <a:prstGeom prst="rect">
-            <a:avLst/>
-          </a:prstGeom>
-        </p:spPr>
-        <p:txBody>
-          <a:bodyPr vert="horz" lIns="91440" tIns="45720" rIns="91440" bIns="45720" rtlCol="0" anchor="b"/>
-          <a:lstStyle>
-            <a:lvl1pPr algn="r">
-              <a:defRPr sz="1200"/>
-            </a:lvl1pPr>
-          </a:lstStyle>
-          <a:p>
-            <a:fld id="{CE5E9CC1-C706-0F49-92D6-E571CC5EEA8F}" type="slidenum">
-              <a:rPr lang="en-US"/>
-              <a:t>‹#›</a:t>
-            </a:fld>
-            <a:endParaRPr lang="en-US"/>
-          </a:p>
-        </p:txBody>
-      </p:sp>
     </p:spTree>
     <p:extLst>
       <p:ext uri="{BB962C8B-B14F-4D97-AF65-F5344CB8AC3E}">
-        <p14:creationId xmlns:p14="http://schemas.microsoft.com/office/powerpoint/2010/main" val="1024086991"/>
+        <p14:creationId xmlns:p14="http://schemas.microsoft.com/office/powerpoint/2010/main" val="1795217646"/>
       </p:ext>
     </p:extLst>
   </p:cSld>
@@ -558,7 +334,6 @@
               <a:rPr lang="en-US" dirty="0"/>
               <a:t>Здравствуйте. SteppeInvoice: один счёт в Solana, и все участники получают свою долю в момент оплаты. На слайде как раз такой платёж: 84% исполнителю, 15% напарнику, 1% сервису.</a:t>
             </a:r>
-            <a:endParaRPr lang="en-US" dirty="0"/>
           </a:p>
         </p:txBody>
       </p:sp>
@@ -644,9 +419,8 @@
           <a:p>
             <a:r>
               <a:rPr lang="en-US" dirty="0"/>
-              <a:t>Я зарабатываю один процент с оплаченного счёта. Не оплатили, значит, ничего не платят. Подписок нет. Комиссию забирает тот же смарт-контракт, поэтому это прозрачно для клиента и исполнителя. Затраты почти не растут с объёмом: сеть берёт доли цента. Дальше возможны платный тариф «Финансы», интеграции и USDC, но это гипотезы, а не факты. Риски назову сразу: оборот пока тестовый, доход зависит от размера среднего счёта, а регулирование крипты в регионе меняется.</a:t>
-            </a:r>
-            <a:endParaRPr lang="en-US" dirty="0"/>
+              <a:t>Я зарабатываю один процент с оплаченного счёта. Не оплатили, значит, ничего не платят. Подписок нет. Комиссия уходит в момент оплаты и видна клиенту и исполнителю. Сейчас её выставляет сайт, зашить её в контракт — задача до основной сети. Затраты почти не растут с объёмом: сеть берёт доли цента. Дальше возможны платный тариф «Финансы», интеграции и USDC, но это гипотезы, а не факты. Риски назову сразу: оборот пока тестовый, доход зависит от размера среднего счёта, а по закону Казахстана криптовалюта не средство платежа, поэтому до реальных платежей нужно заключение юриста.</a:t>
+            </a:r>
           </a:p>
         </p:txBody>
       </p:sp>
@@ -734,7 +508,6 @@
               <a:rPr lang="en-US" dirty="0"/>
               <a:t>Первая аудитория: фрилансеры, IT-аутсорс и небольшие команды в Казахстане, которые получают оплату в крипте и делят её с напарниками. Данные Минфина дают потолок рынка, но не конкретную долю. Привлечение: каждый отправленный счёт показывает продукт новому клиенту через ссылку с превью и кнопкой; Telegram как привычный вход; сообщества Solana и Superteam; интерфейс на трёх языках. Дальше Узбекистан и Кыргызстан.</a:t>
             </a:r>
-            <a:endParaRPr lang="en-US" dirty="0"/>
           </a:p>
         </p:txBody>
       </p:sp>
@@ -820,9 +593,8 @@
           <a:p>
             <a:r>
               <a:rPr lang="en-US" dirty="0"/>
-              <a:t>Сегодня работает: смарт-контракт с атомарным сплитом, сайт на трёх языках, Telegram-бот с демо за один тап, акт с QR-печатью, раздел Финансы и налоги, тридцать четыре автотеста. Всё это в тестовой сети. Дальше: основная сеть, комиссия на уровне контракта, чтобы её нельзя было обойти, оплата в USDC и независимый аудит.</a:t>
-            </a:r>
-            <a:endParaRPr lang="en-US" dirty="0"/>
+              <a:t>Сегодня работает: смарт-контракт с атомарным сплитом, сайт на трёх языках, Telegram-бот с демо за один тап, акт с QR-печатью, раздел Финансы и налоги, тридцать четыре автотеста. Всё это в тестовой сети. Дальше: основная сеть, комиссия на уровне контракта, чтобы её нельзя было обойти, оплата в USDC, заключение юриста и независимый аудит.</a:t>
+            </a:r>
           </a:p>
         </p:txBody>
       </p:sp>
@@ -910,7 +682,6 @@
               <a:rPr lang="en-US" dirty="0"/>
               <a:t>Сейчас покажу за минуту: в боте нажимаю «Попробовать в тестовой сети», бот создаёт счёт, оплачивает его как демо-клиент, и мне приходит уведомление с актом. Всё работает уже сегодня. Спасибо.</a:t>
             </a:r>
-            <a:endParaRPr lang="en-US" dirty="0"/>
           </a:p>
         </p:txBody>
       </p:sp>
@@ -998,7 +769,6 @@
               <a:rPr lang="en-US" dirty="0"/>
               <a:t>Я начал этот проект, чтобы проверить свои силы. Но очень увлёкся и решил по-настоящему понять: есть ли тут проблема? Первое, что мне сказали: зачем это всё, можно просто отправить адрес кошелька Phantom. И это правда. Для перевода. Поэтому я стал смотреть не на сам перевод, а на то, что происходит с фрилансером после него.</a:t>
             </a:r>
-            <a:endParaRPr lang="en-US" dirty="0"/>
           </a:p>
         </p:txBody>
       </p:sp>
@@ -1086,7 +856,6 @@
               <a:rPr lang="en-US" dirty="0"/>
               <a:t>Исполнителю нужен не перевод, а процесс. Работаете вдвоём — значит, надо поделить деньги, и это отдельный перевод с двойной комиссией и доверием на слово. Хочется знать, что заплатили. Клиенту нужен документ для отчётности, а не скриншот. И налоги: по какому режиму, по какому курсу, к какому сроку.</a:t>
             </a:r>
-            <a:endParaRPr lang="en-US" dirty="0"/>
           </a:p>
         </p:txBody>
       </p:sp>
@@ -1174,7 +943,6 @@
               <a:rPr lang="en-US" dirty="0"/>
               <a:t>С первого января 2026 в Казахстане новый Налоговый кодекс, спецрежимов осталось три. По данным Минфина на март: 346 тысяч человек выбрали режим самозанятого, из них 265 тысяч вышли из тени, и 1,2 миллиона предпринимателей выбрали упрощённую декларацию. Честная оговорка: это весь рынок самозанятых и ИП, а не число тех, кто получает крипту. Эту долю ещё предстоит измерить.</a:t>
             </a:r>
-            <a:endParaRPr lang="en-US" dirty="0"/>
           </a:p>
         </p:txBody>
       </p:sp>
@@ -1262,7 +1030,6 @@
               <a:rPr lang="en-US" dirty="0"/>
               <a:t>Отвечу на главное возражение. Если заказчик в крипте и вы работаете один, адрес кошелька действительно достаточен. SteppeInvoice нужен тем, кому нужно поделить деньги с напарником, получить уведомление, дать клиенту документ и посчитать налог: всё это делает одна ссылка.</a:t>
             </a:r>
-            <a:endParaRPr lang="en-US" dirty="0"/>
           </a:p>
         </p:txBody>
       </p:sp>
@@ -1348,9 +1115,8 @@
           <a:p>
             <a:r>
               <a:rPr lang="en-US" dirty="0"/>
-              <a:t>Создаёте счёт, отправляете красивую ссылку, клиент платит в один клик из Phantom, контракт делит деньги в одной транзакции, а вам приходят уведомление в Telegram и документ. Сервис никогда не держит деньги: если один из переводов не прошёл, не списывается ничего.</a:t>
-            </a:r>
-            <a:endParaRPr lang="en-US" dirty="0"/>
+              <a:t>Создаёте счёт, отправляете красивую ссылку, клиент платит из Phantom: первый раз с подсказками на странице, затем в один клик, контракт делит деньги в одной транзакции, а вам приходят уведомление в Telegram и документ. Сервис никогда не держит деньги: если один из переводов не прошёл, не списывается ничего.</a:t>
+            </a:r>
           </a:p>
         </p:txBody>
       </p:sp>
@@ -1436,9 +1202,8 @@
           <a:p>
             <a:r>
               <a:rPr lang="en-US" dirty="0"/>
-              <a:t>Это реальные экраны. Слева страница оплаты: клиент видит название, сумму и распределение денег. Справа акт выполненных работ по форме Р-1 с QR-печатью, на русском, казахском и английском. Всё работает в тестовой сети Solana, демо-данные.</a:t>
-            </a:r>
-            <a:endParaRPr lang="en-US" dirty="0"/>
+              <a:t>Это реальные экраны. Слева страница оплаты: клиент видит название, сумму и распределение денег. Справа акт выполненных работ на основе формы Р-1 с QR-печатью, на русском, казахском и английском. Всё работает в тестовой сети Solana, демо-данные.</a:t>
+            </a:r>
           </a:p>
         </p:txBody>
       </p:sp>
@@ -1526,7 +1291,6 @@
               <a:rPr lang="en-US" dirty="0"/>
               <a:t>Слева Telegram-бот: нажимаете «Попробовать в тестовой сети», бот создаёт счёт, оплачивает его как демо-клиент, и приходит уведомление с актом. Справа страница «Финансы»: доходы из блокчейна и записи вручную, оценка налога по режиму самозанятого или ИП на упрощёнке и ближайшие сроки. Это оценка, а не налоговая консультация, и так написано в интерфейсе.</a:t>
             </a:r>
-            <a:endParaRPr lang="en-US" dirty="0"/>
           </a:p>
         </p:txBody>
       </p:sp>
@@ -1612,9 +1376,8 @@
           <a:p>
             <a:r>
               <a:rPr lang="en-US" dirty="0"/>
-              <a:t>Это реальный барьер, и я говорю о нём сам. Что я сделал: инструкция в четыре шага открывается прямо со страницы оплаты. Один раз потратить десять минут, дальше любой счёт оплачивается в один клик. Оплату картой напрямую я добавлять не буду осознанно: платёжные системы берут свой процент и становятся посредником между клиентом и исполнителем. Идея в том, чтобы деньги шли напрямую, а процент был один и понятный.</a:t>
-            </a:r>
-            <a:endParaRPr lang="en-US" dirty="0"/>
+              <a:t>Это реальный барьер, и я говорю о нём сам. Что я сделал: инструкция в четыре шага открывается прямо со страницы оплаты. Один раз потратить десять минут, дальше любой счёт оплачивается в один клик. Оплату картой напрямую я добавлять не буду осознанно: платёжные системы берут свой процент и становятся посредником между клиентом и исполнителем. Идея в том, чтобы деньги шли напрямую, а наша комиссия была понятной: 1%. Комиссию за покупку SOL Phantom показывает до подтверждения, она не наша.</a:t>
+            </a:r>
           </a:p>
         </p:txBody>
       </p:sp>
@@ -1692,6 +1455,7 @@
         <a:solidFill>
           <a:schemeClr val="tx1"/>
         </a:solidFill>
+        <a:effectLst/>
       </p:bgPr>
     </p:bg>
     <p:spTree>
@@ -1711,9 +1475,11 @@
       <p:sp>
         <p:nvSpPr>
           <p:cNvPr id="2" name="Text 0"/>
-          <p:cNvSpPr/>
+          <p:cNvSpPr>
+            <a:spLocks noGrp="1"/>
+          </p:cNvSpPr>
           <p:nvPr>
-            <p:ph idx="100" type="title" hasCustomPrompt="1"/>
+            <p:ph type="title" idx="100" hasCustomPrompt="1"/>
           </p:nvPr>
         </p:nvSpPr>
         <p:spPr>
@@ -1730,7 +1496,7 @@
         <p:txBody>
           <a:bodyPr wrap="square" rtlCol="0"/>
           <a:lstStyle>
-            <a:lvl1pPr algn="l" indent="0" marL="0">
+            <a:lvl1pPr marL="0" indent="0" algn="l">
               <a:buNone/>
               <a:defRPr lang="en-US" sz="6600" b="1" dirty="0">
                 <a:solidFill>
@@ -1740,7 +1506,7 @@
             </a:lvl1pPr>
           </a:lstStyle>
           <a:p>
-            <a:pPr algn="l" indent="0" marL="0">
+            <a:pPr marL="0" indent="0" algn="l">
               <a:buNone/>
             </a:pPr>
             <a:endParaRPr lang="en-US" sz="6600" dirty="0"/>
@@ -1750,9 +1516,11 @@
       <p:sp>
         <p:nvSpPr>
           <p:cNvPr id="3" name="Text 0"/>
-          <p:cNvSpPr/>
+          <p:cNvSpPr>
+            <a:spLocks noGrp="1"/>
+          </p:cNvSpPr>
           <p:nvPr>
-            <p:ph idx="101" type="body" hasCustomPrompt="1"/>
+            <p:ph type="body" idx="101" hasCustomPrompt="1"/>
           </p:nvPr>
         </p:nvSpPr>
         <p:spPr>
@@ -1769,7 +1537,7 @@
         <p:txBody>
           <a:bodyPr wrap="square" rtlCol="0"/>
           <a:lstStyle>
-            <a:lvl1pPr algn="l" indent="0" marL="0">
+            <a:lvl1pPr marL="0" indent="0" algn="l">
               <a:buNone/>
               <a:defRPr lang="en-US" sz="3000" dirty="0">
                 <a:solidFill>
@@ -1779,7 +1547,7 @@
             </a:lvl1pPr>
           </a:lstStyle>
           <a:p>
-            <a:pPr algn="l" indent="0" marL="0">
+            <a:pPr marL="0" indent="0" algn="l">
               <a:buNone/>
             </a:pPr>
             <a:endParaRPr lang="en-US" sz="3000" dirty="0"/>
@@ -1802,6 +1570,7 @@
         <a:solidFill>
           <a:schemeClr val="tx1"/>
         </a:solidFill>
+        <a:effectLst/>
       </p:bgPr>
     </p:bg>
     <p:spTree>
@@ -1821,9 +1590,11 @@
       <p:sp>
         <p:nvSpPr>
           <p:cNvPr id="2" name="Text 0"/>
-          <p:cNvSpPr/>
+          <p:cNvSpPr>
+            <a:spLocks noGrp="1"/>
+          </p:cNvSpPr>
           <p:nvPr>
-            <p:ph idx="100" type="title" hasCustomPrompt="1"/>
+            <p:ph type="title" idx="100" hasCustomPrompt="1"/>
           </p:nvPr>
         </p:nvSpPr>
         <p:spPr>
@@ -1840,7 +1611,7 @@
         <p:txBody>
           <a:bodyPr wrap="square" rtlCol="0"/>
           <a:lstStyle>
-            <a:lvl1pPr algn="l" indent="0" marL="0">
+            <a:lvl1pPr marL="0" indent="0" algn="l">
               <a:buNone/>
               <a:defRPr lang="en-US" sz="3200" b="1" dirty="0">
                 <a:solidFill>
@@ -1850,7 +1621,7 @@
             </a:lvl1pPr>
           </a:lstStyle>
           <a:p>
-            <a:pPr algn="l" indent="0" marL="0">
+            <a:pPr marL="0" indent="0" algn="l">
               <a:buNone/>
             </a:pPr>
             <a:endParaRPr lang="en-US" sz="3200" dirty="0"/>
@@ -1878,7 +1649,7 @@
           <a:bodyPr wrap="square" lIns="0" tIns="0" rIns="0" bIns="0" rtlCol="0" anchor="ctr"/>
           <a:lstStyle/>
           <a:p>
-            <a:pPr indent="0" marL="0">
+            <a:pPr marL="0" indent="0">
               <a:buNone/>
             </a:pPr>
             <a:r>
@@ -1913,7 +1684,7 @@
           </a:prstGeom>
           <a:extLst>
             <a:ext uri="{C572A759-6A51-4108-AA02-DFA0A04FC94B}">
-              <ma14:wrappingTextBoxFlag xmlns:ma14="http://schemas.microsoft.com/office/mac/drawingml/2011/main" val="0"/>
+              <ma14:wrappingTextBoxFlag xmlns:ma14="http://schemas.microsoft.com/office/mac/drawingml/2011/main" xmlns="" val="0"/>
             </a:ext>
           </a:extLst>
         </p:spPr>
@@ -1931,8 +1702,8 @@
           <a:p>
             <a:pPr algn="r"/>
             <a:fld id="{F7021451-1387-4CA6-816F-3879F97B5CBC}" type="slidenum">
-              <a:rPr b="0" lang="en-US"/>
-              <a:t>1003</a:t>
+              <a:rPr lang="en-US" b="0"/>
+              <a:t>‹#›</a:t>
             </a:fld>
             <a:endParaRPr lang="en-US"/>
           </a:p>
@@ -1949,6 +1720,11 @@
 <file path=ppt/slideMasters/slideMaster1.xml><?xml version="1.0" encoding="utf-8"?>
 <p:sldMaster xmlns:a="http://schemas.openxmlformats.org/drawingml/2006/main" xmlns:r="http://schemas.openxmlformats.org/officeDocument/2006/relationships" xmlns:p="http://schemas.openxmlformats.org/presentationml/2006/main">
   <p:cSld>
+    <p:bg>
+      <p:bgRef idx="1001">
+        <a:schemeClr val="bg1"/>
+      </p:bgRef>
+    </p:bg>
     <p:spTree>
       <p:nvGrpSpPr>
         <p:cNvPr id="1" name=""/>
@@ -1983,7 +1759,7 @@
           </a:prstGeom>
           <a:extLst>
             <a:ext uri="{C572A759-6A51-4108-AA02-DFA0A04FC94B}">
-              <ma14:wrappingTextBoxFlag xmlns:ma14="http://schemas.microsoft.com/office/mac/drawingml/2011/main" val="0"/>
+              <ma14:wrappingTextBoxFlag xmlns:ma14="http://schemas.microsoft.com/office/mac/drawingml/2011/main" xmlns="" val="0"/>
             </a:ext>
           </a:extLst>
         </p:spPr>
@@ -2001,8 +1777,8 @@
           <a:p>
             <a:pPr algn="r"/>
             <a:fld id="{F7021451-1387-4CA6-816F-3879F97B5CBC}" type="slidenum">
-              <a:rPr b="0" lang="en-US"/>
-              <a:t>null</a:t>
+              <a:rPr lang="en-US" b="0"/>
+              <a:t>‹#›</a:t>
             </a:fld>
             <a:endParaRPr lang="en-US"/>
           </a:p>
@@ -2290,9 +2066,11 @@
       <p:sp>
         <p:nvSpPr>
           <p:cNvPr id="2" name="Text 0"/>
-          <p:cNvSpPr/>
+          <p:cNvSpPr>
+            <a:spLocks noGrp="1"/>
+          </p:cNvSpPr>
           <p:nvPr>
-            <p:ph idx="100" type="title" hasCustomPrompt="1"/>
+            <p:ph type="title" idx="100" hasCustomPrompt="1"/>
           </p:nvPr>
         </p:nvSpPr>
         <p:spPr>
@@ -2310,7 +2088,7 @@
           <a:bodyPr wrap="square" lIns="0" tIns="0" rIns="0" bIns="0" rtlCol="0" anchor="b"/>
           <a:lstStyle/>
           <a:p>
-            <a:pPr algn="l" indent="0" marL="0">
+            <a:pPr marL="0" indent="0" algn="l">
               <a:buNone/>
             </a:pPr>
             <a:r>
@@ -2328,9 +2106,11 @@
       <p:sp>
         <p:nvSpPr>
           <p:cNvPr id="3" name="Text 0"/>
-          <p:cNvSpPr/>
+          <p:cNvSpPr>
+            <a:spLocks noGrp="1"/>
+          </p:cNvSpPr>
           <p:nvPr>
-            <p:ph idx="101" type="body" hasCustomPrompt="1"/>
+            <p:ph type="body" idx="101" hasCustomPrompt="1"/>
           </p:nvPr>
         </p:nvSpPr>
         <p:spPr>
@@ -2348,7 +2128,7 @@
           <a:bodyPr wrap="square" lIns="0" tIns="0" rIns="0" bIns="0" rtlCol="0" anchor="t"/>
           <a:lstStyle/>
           <a:p>
-            <a:pPr algn="l" indent="0" marL="0">
+            <a:pPr marL="0" indent="0" algn="l">
               <a:buNone/>
             </a:pPr>
             <a:r>
@@ -2357,7 +2137,23 @@
                   <a:schemeClr val="accent1"/>
                 </a:solidFill>
               </a:rPr>
-              <a:t>Один счёт — все получают свою долю</a:t>
+              <a:t>Один </a:t>
+            </a:r>
+            <a:r>
+              <a:rPr lang="en-US" sz="3000" dirty="0" err="1">
+                <a:solidFill>
+                  <a:schemeClr val="accent1"/>
+                </a:solidFill>
+              </a:rPr>
+              <a:t>счёт</a:t>
+            </a:r>
+            <a:r>
+              <a:rPr lang="en-US" sz="3000" dirty="0">
+                <a:solidFill>
+                  <a:schemeClr val="accent1"/>
+                </a:solidFill>
+              </a:rPr>
+              <a:t> - все получают свою долю</a:t>
             </a:r>
             <a:endParaRPr lang="en-US" sz="3000" dirty="0"/>
           </a:p>
@@ -2384,7 +2180,7 @@
           <a:bodyPr wrap="square" lIns="0" tIns="0" rIns="0" bIns="0" rtlCol="0" anchor="t"/>
           <a:lstStyle/>
           <a:p>
-            <a:pPr indent="0" marL="0">
+            <a:pPr marL="0" indent="0">
               <a:buNone/>
             </a:pPr>
             <a:r>
@@ -2495,7 +2291,7 @@
           <a:bodyPr wrap="square" lIns="0" tIns="0" rIns="0" bIns="0" rtlCol="0" anchor="t"/>
           <a:lstStyle/>
           <a:p>
-            <a:pPr indent="0" marL="0">
+            <a:pPr marL="0" indent="0">
               <a:buNone/>
             </a:pPr>
             <a:r>
@@ -2531,7 +2327,7 @@
           <a:bodyPr wrap="square" lIns="0" tIns="0" rIns="0" bIns="0" rtlCol="0" anchor="t"/>
           <a:lstStyle/>
           <a:p>
-            <a:pPr algn="r" indent="0" marL="0">
+            <a:pPr marL="0" indent="0" algn="r">
               <a:buNone/>
             </a:pPr>
             <a:r>
@@ -2567,7 +2363,7 @@
           <a:bodyPr wrap="square" lIns="0" tIns="0" rIns="0" bIns="0" rtlCol="0" anchor="t"/>
           <a:lstStyle/>
           <a:p>
-            <a:pPr algn="r" indent="0" marL="0">
+            <a:pPr marL="0" indent="0" algn="r">
               <a:buNone/>
             </a:pPr>
             <a:r>
@@ -2603,7 +2399,7 @@
           <a:bodyPr wrap="square" lIns="0" tIns="0" rIns="0" bIns="0" rtlCol="0" anchor="t"/>
           <a:lstStyle/>
           <a:p>
-            <a:pPr indent="0" marL="0">
+            <a:pPr marL="0" indent="0">
               <a:buNone/>
             </a:pPr>
             <a:r>
@@ -2646,9 +2442,11 @@
       <p:sp>
         <p:nvSpPr>
           <p:cNvPr id="2" name="Text 0"/>
-          <p:cNvSpPr/>
+          <p:cNvSpPr>
+            <a:spLocks noGrp="1"/>
+          </p:cNvSpPr>
           <p:nvPr>
-            <p:ph idx="100" type="title" hasCustomPrompt="1"/>
+            <p:ph type="title" idx="100" hasCustomPrompt="1"/>
           </p:nvPr>
         </p:nvSpPr>
         <p:spPr>
@@ -2666,7 +2464,7 @@
           <a:bodyPr wrap="square" lIns="0" tIns="0" rIns="0" bIns="0" rtlCol="0" anchor="t"/>
           <a:lstStyle/>
           <a:p>
-            <a:pPr algn="l" indent="0" marL="0">
+            <a:pPr marL="0" indent="0" algn="l">
               <a:buNone/>
             </a:pPr>
             <a:r>
@@ -2707,6 +2505,10 @@
             <a:prstDash val="solid"/>
           </a:ln>
         </p:spPr>
+        <p:txBody>
+          <a:bodyPr/>
+          <a:p/>
+        </p:txBody>
       </p:sp>
       <p:sp>
         <p:nvSpPr>
@@ -2729,7 +2531,7 @@
           <a:bodyPr wrap="square" lIns="0" tIns="0" rIns="0" bIns="0" rtlCol="0" anchor="t"/>
           <a:lstStyle/>
           <a:p>
-            <a:pPr indent="0" marL="0">
+            <a:pPr marL="0" indent="0">
               <a:buNone/>
             </a:pPr>
             <a:r>
@@ -2765,7 +2567,7 @@
           <a:bodyPr wrap="square" lIns="0" tIns="0" rIns="0" bIns="0" rtlCol="0" anchor="t"/>
           <a:lstStyle/>
           <a:p>
-            <a:pPr indent="0" marL="0">
+            <a:pPr marL="0" indent="0">
               <a:buNone/>
             </a:pPr>
             <a:r>
@@ -2806,6 +2608,10 @@
             <a:prstDash val="solid"/>
           </a:ln>
         </p:spPr>
+        <p:txBody>
+          <a:bodyPr/>
+          <a:p/>
+        </p:txBody>
       </p:sp>
       <p:sp>
         <p:nvSpPr>
@@ -2828,7 +2634,7 @@
           <a:bodyPr wrap="square" lIns="0" tIns="0" rIns="0" bIns="0" rtlCol="0" anchor="t"/>
           <a:lstStyle/>
           <a:p>
-            <a:pPr indent="0" marL="0">
+            <a:pPr marL="0" indent="0">
               <a:buNone/>
             </a:pPr>
             <a:r>
@@ -2877,7 +2683,7 @@
                   <a:schemeClr val="bg1"/>
                 </a:solidFill>
               </a:rPr>
-              <a:t>Комиссию забирает контракт в момент оплаты</a:t>
+              <a:t>Комиссия уходит в момент оплаты; в контракт её ещё надо зашить</a:t>
             </a:r>
             <a:endParaRPr lang="en-US" sz="1600" dirty="0"/>
           </a:p>
@@ -2942,6 +2748,10 @@
             <a:prstDash val="solid"/>
           </a:ln>
         </p:spPr>
+        <p:txBody>
+          <a:bodyPr/>
+          <a:p/>
+        </p:txBody>
       </p:sp>
       <p:sp>
         <p:nvSpPr>
@@ -2964,7 +2774,7 @@
           <a:bodyPr wrap="square" lIns="0" tIns="0" rIns="0" bIns="0" rtlCol="0" anchor="t"/>
           <a:lstStyle/>
           <a:p>
-            <a:pPr indent="0" marL="0">
+            <a:pPr marL="0" indent="0">
               <a:buNone/>
             </a:pPr>
             <a:r>
@@ -3073,7 +2883,7 @@
           <a:bodyPr wrap="square" lIns="0" tIns="0" rIns="0" bIns="0" rtlCol="0" anchor="t"/>
           <a:lstStyle/>
           <a:p>
-            <a:pPr indent="0" marL="0">
+            <a:pPr marL="0" indent="0">
               <a:buNone/>
             </a:pPr>
             <a:r>
@@ -3082,7 +2892,7 @@
                   <a:schemeClr val="bg2"/>
                 </a:solidFill>
               </a:rPr>
-              <a:t>Риски: оборот пока тестовый; доход зависит от размера среднего счёта; регулирование крипты в регионе меняется</a:t>
+              <a:t>Риски: оборот пока тестовый; доход зависит от размера среднего счёта; по закону РК крипта не средство платежа, нужен юрист</a:t>
             </a:r>
             <a:endParaRPr lang="en-US" sz="1400" dirty="0"/>
           </a:p>
@@ -3108,7 +2918,7 @@
           </a:prstGeom>
           <a:extLst>
             <a:ext uri="{C572A759-6A51-4108-AA02-DFA0A04FC94B}">
-              <ma14:wrappingTextBoxFlag xmlns:ma14="http://schemas.microsoft.com/office/mac/drawingml/2011/main" val="0"/>
+              <ma14:wrappingTextBoxFlag xmlns:ma14="http://schemas.microsoft.com/office/mac/drawingml/2011/main" xmlns="" val="0"/>
             </a:ext>
           </a:extLst>
         </p:spPr>
@@ -3126,7 +2936,7 @@
           <a:p>
             <a:pPr algn="r"/>
             <a:fld id="{F7021451-1387-4CA6-816F-3879F97B5CBC}" type="slidenum">
-              <a:rPr b="0" lang="en-US"/>
+              <a:rPr lang="en-US" b="0"/>
               <a:t>10</a:t>
             </a:fld>
             <a:endParaRPr lang="en-US"/>
@@ -3161,9 +2971,11 @@
       <p:sp>
         <p:nvSpPr>
           <p:cNvPr id="2" name="Text 0"/>
-          <p:cNvSpPr/>
+          <p:cNvSpPr>
+            <a:spLocks noGrp="1"/>
+          </p:cNvSpPr>
           <p:nvPr>
-            <p:ph idx="100" type="title" hasCustomPrompt="1"/>
+            <p:ph type="title" idx="100" hasCustomPrompt="1"/>
           </p:nvPr>
         </p:nvSpPr>
         <p:spPr>
@@ -3181,7 +2993,7 @@
           <a:bodyPr wrap="square" lIns="0" tIns="0" rIns="0" bIns="0" rtlCol="0" anchor="t"/>
           <a:lstStyle/>
           <a:p>
-            <a:pPr algn="l" indent="0" marL="0">
+            <a:pPr marL="0" indent="0" algn="l">
               <a:buNone/>
             </a:pPr>
             <a:r>
@@ -3222,6 +3034,10 @@
             <a:prstDash val="solid"/>
           </a:ln>
         </p:spPr>
+        <p:txBody>
+          <a:bodyPr/>
+          <a:p/>
+        </p:txBody>
       </p:sp>
       <p:sp>
         <p:nvSpPr>
@@ -3244,7 +3060,7 @@
           <a:bodyPr wrap="square" lIns="0" tIns="0" rIns="0" bIns="0" rtlCol="0" anchor="t"/>
           <a:lstStyle/>
           <a:p>
-            <a:pPr indent="0" marL="0">
+            <a:pPr marL="0" indent="0">
               <a:buNone/>
             </a:pPr>
             <a:r>
@@ -3326,7 +3142,7 @@
                   <a:schemeClr val="bg1"/>
                 </a:solidFill>
               </a:rPr>
-              <a:t>Потолок рынка: 346 тыс. самозанятых и 1,2 млн ИП на упрощёнке (не все получают крипту)</a:t>
+              <a:t>Потолок рынка: 1,2 млн ИП на упрощёнке и 346 тыс. самозанятых (не все получают крипту)</a:t>
             </a:r>
             <a:endParaRPr lang="en-US" sz="1500" dirty="0"/>
           </a:p>
@@ -3358,6 +3174,10 @@
             <a:prstDash val="solid"/>
           </a:ln>
         </p:spPr>
+        <p:txBody>
+          <a:bodyPr/>
+          <a:p/>
+        </p:txBody>
       </p:sp>
       <p:sp>
         <p:nvSpPr>
@@ -3383,17 +3203,21 @@
             <a:prstDash val="solid"/>
           </a:ln>
         </p:spPr>
+        <p:txBody>
+          <a:bodyPr/>
+          <a:p/>
+        </p:txBody>
       </p:sp>
       <p:pic>
         <p:nvPicPr>
-          <p:cNvPr id="9" name="Image 0" descr="link">    </p:cNvPr>
+          <p:cNvPr id="9" name="Image 0" descr="link"/>
           <p:cNvPicPr>
             <a:picLocks noChangeAspect="1"/>
           </p:cNvPicPr>
           <p:nvPr/>
         </p:nvPicPr>
         <p:blipFill>
-          <a:blip r:embed="rId1"/>
+          <a:blip r:embed="rId3"/>
           <a:stretch>
             <a:fillRect/>
           </a:stretch>
@@ -3429,7 +3253,7 @@
           <a:bodyPr wrap="square" lIns="0" tIns="0" rIns="0" bIns="0" rtlCol="0" anchor="t"/>
           <a:lstStyle/>
           <a:p>
-            <a:pPr indent="0" marL="0">
+            <a:pPr marL="0" indent="0">
               <a:buNone/>
             </a:pPr>
             <a:r>
@@ -3465,7 +3289,7 @@
           <a:bodyPr wrap="square" lIns="0" tIns="0" rIns="0" bIns="0" rtlCol="0" anchor="t"/>
           <a:lstStyle/>
           <a:p>
-            <a:pPr indent="0" marL="0">
+            <a:pPr marL="0" indent="0">
               <a:buNone/>
             </a:pPr>
             <a:r>
@@ -3506,6 +3330,10 @@
             <a:prstDash val="solid"/>
           </a:ln>
         </p:spPr>
+        <p:txBody>
+          <a:bodyPr/>
+          <a:p/>
+        </p:txBody>
       </p:sp>
       <p:sp>
         <p:nvSpPr>
@@ -3531,17 +3359,21 @@
             <a:prstDash val="solid"/>
           </a:ln>
         </p:spPr>
+        <p:txBody>
+          <a:bodyPr/>
+          <a:p/>
+        </p:txBody>
       </p:sp>
       <p:pic>
         <p:nvPicPr>
-          <p:cNvPr id="14" name="Image 1" descr="tg">    </p:cNvPr>
+          <p:cNvPr id="14" name="Image 1" descr="tg"/>
           <p:cNvPicPr>
             <a:picLocks noChangeAspect="1"/>
           </p:cNvPicPr>
           <p:nvPr/>
         </p:nvPicPr>
         <p:blipFill>
-          <a:blip r:embed="rId2"/>
+          <a:blip r:embed="rId4"/>
           <a:stretch>
             <a:fillRect/>
           </a:stretch>
@@ -3577,7 +3409,7 @@
           <a:bodyPr wrap="square" lIns="0" tIns="0" rIns="0" bIns="0" rtlCol="0" anchor="t"/>
           <a:lstStyle/>
           <a:p>
-            <a:pPr indent="0" marL="0">
+            <a:pPr marL="0" indent="0">
               <a:buNone/>
             </a:pPr>
             <a:r>
@@ -3613,7 +3445,7 @@
           <a:bodyPr wrap="square" lIns="0" tIns="0" rIns="0" bIns="0" rtlCol="0" anchor="t"/>
           <a:lstStyle/>
           <a:p>
-            <a:pPr indent="0" marL="0">
+            <a:pPr marL="0" indent="0">
               <a:buNone/>
             </a:pPr>
             <a:r>
@@ -3654,6 +3486,10 @@
             <a:prstDash val="solid"/>
           </a:ln>
         </p:spPr>
+        <p:txBody>
+          <a:bodyPr/>
+          <a:p/>
+        </p:txBody>
       </p:sp>
       <p:sp>
         <p:nvSpPr>
@@ -3679,17 +3515,21 @@
             <a:prstDash val="solid"/>
           </a:ln>
         </p:spPr>
+        <p:txBody>
+          <a:bodyPr/>
+          <a:p/>
+        </p:txBody>
       </p:sp>
       <p:pic>
         <p:nvPicPr>
-          <p:cNvPr id="19" name="Image 2" descr="globe">    </p:cNvPr>
+          <p:cNvPr id="19" name="Image 2" descr="globe"/>
           <p:cNvPicPr>
             <a:picLocks noChangeAspect="1"/>
           </p:cNvPicPr>
           <p:nvPr/>
         </p:nvPicPr>
         <p:blipFill>
-          <a:blip r:embed="rId3"/>
+          <a:blip r:embed="rId5"/>
           <a:stretch>
             <a:fillRect/>
           </a:stretch>
@@ -3725,7 +3565,7 @@
           <a:bodyPr wrap="square" lIns="0" tIns="0" rIns="0" bIns="0" rtlCol="0" anchor="t"/>
           <a:lstStyle/>
           <a:p>
-            <a:pPr indent="0" marL="0">
+            <a:pPr marL="0" indent="0">
               <a:buNone/>
             </a:pPr>
             <a:r>
@@ -3761,7 +3601,7 @@
           <a:bodyPr wrap="square" lIns="0" tIns="0" rIns="0" bIns="0" rtlCol="0" anchor="t"/>
           <a:lstStyle/>
           <a:p>
-            <a:pPr indent="0" marL="0">
+            <a:pPr marL="0" indent="0">
               <a:buNone/>
             </a:pPr>
             <a:r>
@@ -3802,6 +3642,10 @@
             <a:prstDash val="solid"/>
           </a:ln>
         </p:spPr>
+        <p:txBody>
+          <a:bodyPr/>
+          <a:p/>
+        </p:txBody>
       </p:sp>
       <p:sp>
         <p:nvSpPr>
@@ -3827,17 +3671,21 @@
             <a:prstDash val="solid"/>
           </a:ln>
         </p:spPr>
+        <p:txBody>
+          <a:bodyPr/>
+          <a:p/>
+        </p:txBody>
       </p:sp>
       <p:pic>
         <p:nvPicPr>
-          <p:cNvPr id="24" name="Image 3" descr="flag">    </p:cNvPr>
+          <p:cNvPr id="24" name="Image 3" descr="flag"/>
           <p:cNvPicPr>
             <a:picLocks noChangeAspect="1"/>
           </p:cNvPicPr>
           <p:nvPr/>
         </p:nvPicPr>
         <p:blipFill>
-          <a:blip r:embed="rId4"/>
+          <a:blip r:embed="rId6"/>
           <a:stretch>
             <a:fillRect/>
           </a:stretch>
@@ -3873,7 +3721,7 @@
           <a:bodyPr wrap="square" lIns="0" tIns="0" rIns="0" bIns="0" rtlCol="0" anchor="t"/>
           <a:lstStyle/>
           <a:p>
-            <a:pPr indent="0" marL="0">
+            <a:pPr marL="0" indent="0">
               <a:buNone/>
             </a:pPr>
             <a:r>
@@ -3909,7 +3757,7 @@
           <a:bodyPr wrap="square" lIns="0" tIns="0" rIns="0" bIns="0" rtlCol="0" anchor="t"/>
           <a:lstStyle/>
           <a:p>
-            <a:pPr indent="0" marL="0">
+            <a:pPr marL="0" indent="0">
               <a:buNone/>
             </a:pPr>
             <a:r>
@@ -3926,7 +3774,7 @@
       </p:sp>
       <p:sp>
         <p:nvSpPr>
-          <p:cNvPr id="25" name="Slide Number Placeholder 0"/>
+          <p:cNvPr id="3" name="Slide Number Placeholder 0"/>
           <p:cNvSpPr>
             <a:spLocks noGrp="1"/>
           </p:cNvSpPr>
@@ -3944,7 +3792,7 @@
           </a:prstGeom>
           <a:extLst>
             <a:ext uri="{C572A759-6A51-4108-AA02-DFA0A04FC94B}">
-              <ma14:wrappingTextBoxFlag xmlns:ma14="http://schemas.microsoft.com/office/mac/drawingml/2011/main" val="0"/>
+              <ma14:wrappingTextBoxFlag xmlns:ma14="http://schemas.microsoft.com/office/mac/drawingml/2011/main" xmlns="" val="0"/>
             </a:ext>
           </a:extLst>
         </p:spPr>
@@ -3962,7 +3810,7 @@
           <a:p>
             <a:pPr algn="r"/>
             <a:fld id="{F7021451-1387-4CA6-816F-3879F97B5CBC}" type="slidenum">
-              <a:rPr b="0" lang="en-US"/>
+              <a:rPr lang="en-US" b="0"/>
               <a:t>11</a:t>
             </a:fld>
             <a:endParaRPr lang="en-US"/>
@@ -3997,9 +3845,11 @@
       <p:sp>
         <p:nvSpPr>
           <p:cNvPr id="2" name="Text 0"/>
-          <p:cNvSpPr/>
+          <p:cNvSpPr>
+            <a:spLocks noGrp="1"/>
+          </p:cNvSpPr>
           <p:nvPr>
-            <p:ph idx="100" type="title" hasCustomPrompt="1"/>
+            <p:ph type="title" idx="100" hasCustomPrompt="1"/>
           </p:nvPr>
         </p:nvSpPr>
         <p:spPr>
@@ -4017,7 +3867,7 @@
           <a:bodyPr wrap="square" lIns="0" tIns="0" rIns="0" bIns="0" rtlCol="0" anchor="t"/>
           <a:lstStyle/>
           <a:p>
-            <a:pPr algn="l" indent="0" marL="0">
+            <a:pPr marL="0" indent="0" algn="l">
               <a:buNone/>
             </a:pPr>
             <a:r>
@@ -4058,6 +3908,10 @@
             <a:prstDash val="solid"/>
           </a:ln>
         </p:spPr>
+        <p:txBody>
+          <a:bodyPr/>
+          <a:p/>
+        </p:txBody>
       </p:sp>
       <p:sp>
         <p:nvSpPr>
@@ -4080,7 +3934,7 @@
           <a:bodyPr wrap="square" lIns="0" tIns="0" rIns="0" bIns="0" rtlCol="0" anchor="t"/>
           <a:lstStyle/>
           <a:p>
-            <a:pPr indent="0" marL="0">
+            <a:pPr marL="0" indent="0">
               <a:buNone/>
             </a:pPr>
             <a:r>
@@ -4097,127 +3951,7 @@
       </p:sp>
       <p:pic>
         <p:nvPicPr>
-          <p:cNvPr id="6" name="Image 0" descr="готово">    </p:cNvPr>
-          <p:cNvPicPr>
-            <a:picLocks noChangeAspect="1"/>
-          </p:cNvPicPr>
-          <p:nvPr/>
-        </p:nvPicPr>
-        <p:blipFill>
-          <a:blip r:embed="rId1"/>
-          <a:stretch>
-            <a:fillRect/>
-          </a:stretch>
-        </p:blipFill>
-        <p:spPr>
-          <a:xfrm>
-            <a:off x="914400" y="2587752"/>
-            <a:ext cx="274320" cy="274320"/>
-          </a:xfrm>
-          <a:prstGeom prst="rect">
-            <a:avLst/>
-          </a:prstGeom>
-        </p:spPr>
-      </p:pic>
-      <p:sp>
-        <p:nvSpPr>
-          <p:cNvPr id="7" name="Text 3"/>
-          <p:cNvSpPr txBox="1"/>
-          <p:nvPr/>
-        </p:nvSpPr>
-        <p:spPr>
-          <a:xfrm>
-            <a:off x="1371600" y="2560320"/>
-            <a:ext cx="4937760" cy="365760"/>
-          </a:xfrm>
-          <a:prstGeom prst="rect">
-            <a:avLst/>
-          </a:prstGeom>
-          <a:noFill/>
-          <a:ln/>
-        </p:spPr>
-        <p:txBody>
-          <a:bodyPr wrap="square" lIns="0" tIns="0" rIns="0" bIns="0" rtlCol="0" anchor="t"/>
-          <a:lstStyle/>
-          <a:p>
-            <a:pPr indent="0" marL="0">
-              <a:buNone/>
-            </a:pPr>
-            <a:r>
-              <a:rPr lang="en-US" sz="1600" dirty="0">
-                <a:solidFill>
-                  <a:schemeClr val="bg1"/>
-                </a:solidFill>
-              </a:rPr>
-              <a:t>Смарт-контракт Solana с атомарным сплитом</a:t>
-            </a:r>
-            <a:endParaRPr lang="en-US" sz="1600" dirty="0"/>
-          </a:p>
-        </p:txBody>
-      </p:sp>
-      <p:pic>
-        <p:nvPicPr>
-          <p:cNvPr id="8" name="Image 1" descr="готово">    </p:cNvPr>
-          <p:cNvPicPr>
-            <a:picLocks noChangeAspect="1"/>
-          </p:cNvPicPr>
-          <p:nvPr/>
-        </p:nvPicPr>
-        <p:blipFill>
-          <a:blip r:embed="rId2"/>
-          <a:stretch>
-            <a:fillRect/>
-          </a:stretch>
-        </p:blipFill>
-        <p:spPr>
-          <a:xfrm>
-            <a:off x="914400" y="3118104"/>
-            <a:ext cx="274320" cy="274320"/>
-          </a:xfrm>
-          <a:prstGeom prst="rect">
-            <a:avLst/>
-          </a:prstGeom>
-        </p:spPr>
-      </p:pic>
-      <p:sp>
-        <p:nvSpPr>
-          <p:cNvPr id="9" name="Text 4"/>
-          <p:cNvSpPr txBox="1"/>
-          <p:nvPr/>
-        </p:nvSpPr>
-        <p:spPr>
-          <a:xfrm>
-            <a:off x="1371600" y="3090672"/>
-            <a:ext cx="4937760" cy="365760"/>
-          </a:xfrm>
-          <a:prstGeom prst="rect">
-            <a:avLst/>
-          </a:prstGeom>
-          <a:noFill/>
-          <a:ln/>
-        </p:spPr>
-        <p:txBody>
-          <a:bodyPr wrap="square" lIns="0" tIns="0" rIns="0" bIns="0" rtlCol="0" anchor="t"/>
-          <a:lstStyle/>
-          <a:p>
-            <a:pPr indent="0" marL="0">
-              <a:buNone/>
-            </a:pPr>
-            <a:r>
-              <a:rPr lang="en-US" sz="1600" dirty="0">
-                <a:solidFill>
-                  <a:schemeClr val="bg1"/>
-                </a:solidFill>
-              </a:rPr>
-              <a:t>Сайт на трёх языках: RU, KZ, EN</a:t>
-            </a:r>
-            <a:endParaRPr lang="en-US" sz="1600" dirty="0"/>
-          </a:p>
-        </p:txBody>
-      </p:sp>
-      <p:pic>
-        <p:nvPicPr>
-          <p:cNvPr id="10" name="Image 2" descr="готово">    </p:cNvPr>
+          <p:cNvPr id="6" name="Image 0" descr="готово"/>
           <p:cNvPicPr>
             <a:picLocks noChangeAspect="1"/>
           </p:cNvPicPr>
@@ -4231,7 +3965,7 @@
         </p:blipFill>
         <p:spPr>
           <a:xfrm>
-            <a:off x="914400" y="3648456"/>
+            <a:off x="914400" y="2587752"/>
             <a:ext cx="274320" cy="274320"/>
           </a:xfrm>
           <a:prstGeom prst="rect">
@@ -4241,13 +3975,13 @@
       </p:pic>
       <p:sp>
         <p:nvSpPr>
-          <p:cNvPr id="11" name="Text 5"/>
+          <p:cNvPr id="7" name="Text 3"/>
           <p:cNvSpPr txBox="1"/>
           <p:nvPr/>
         </p:nvSpPr>
         <p:spPr>
           <a:xfrm>
-            <a:off x="1371600" y="3621024"/>
+            <a:off x="1371600" y="2560320"/>
             <a:ext cx="4937760" cy="365760"/>
           </a:xfrm>
           <a:prstGeom prst="rect">
@@ -4260,7 +3994,7 @@
           <a:bodyPr wrap="square" lIns="0" tIns="0" rIns="0" bIns="0" rtlCol="0" anchor="t"/>
           <a:lstStyle/>
           <a:p>
-            <a:pPr indent="0" marL="0">
+            <a:pPr marL="0" indent="0">
               <a:buNone/>
             </a:pPr>
             <a:r>
@@ -4269,7 +4003,7 @@
                   <a:schemeClr val="bg1"/>
                 </a:solidFill>
               </a:rPr>
-              <a:t>Telegram-бот: весь путь за один тап</a:t>
+              <a:t>Смарт-контракт Solana с атомарным сплитом</a:t>
             </a:r>
             <a:endParaRPr lang="en-US" sz="1600" dirty="0"/>
           </a:p>
@@ -4277,21 +4011,21 @@
       </p:sp>
       <p:pic>
         <p:nvPicPr>
-          <p:cNvPr id="12" name="Image 3" descr="готово">    </p:cNvPr>
+          <p:cNvPr id="8" name="Image 1" descr="готово"/>
           <p:cNvPicPr>
             <a:picLocks noChangeAspect="1"/>
           </p:cNvPicPr>
           <p:nvPr/>
         </p:nvPicPr>
         <p:blipFill>
-          <a:blip r:embed="rId4"/>
+          <a:blip r:embed="rId3"/>
           <a:stretch>
             <a:fillRect/>
           </a:stretch>
         </p:blipFill>
         <p:spPr>
           <a:xfrm>
-            <a:off x="914400" y="4178808"/>
+            <a:off x="914400" y="3118104"/>
             <a:ext cx="274320" cy="274320"/>
           </a:xfrm>
           <a:prstGeom prst="rect">
@@ -4301,13 +4035,13 @@
       </p:pic>
       <p:sp>
         <p:nvSpPr>
-          <p:cNvPr id="13" name="Text 6"/>
+          <p:cNvPr id="9" name="Text 4"/>
           <p:cNvSpPr txBox="1"/>
           <p:nvPr/>
         </p:nvSpPr>
         <p:spPr>
           <a:xfrm>
-            <a:off x="1371600" y="4151376"/>
+            <a:off x="1371600" y="3090672"/>
             <a:ext cx="4937760" cy="365760"/>
           </a:xfrm>
           <a:prstGeom prst="rect">
@@ -4320,7 +4054,7 @@
           <a:bodyPr wrap="square" lIns="0" tIns="0" rIns="0" bIns="0" rtlCol="0" anchor="t"/>
           <a:lstStyle/>
           <a:p>
-            <a:pPr indent="0" marL="0">
+            <a:pPr marL="0" indent="0">
               <a:buNone/>
             </a:pPr>
             <a:r>
@@ -4329,7 +4063,7 @@
                   <a:schemeClr val="bg1"/>
                 </a:solidFill>
               </a:rPr>
-              <a:t>Акт выполненных работ с QR-печатью</a:t>
+              <a:t>Сайт на трёх языках: RU, KZ, EN</a:t>
             </a:r>
             <a:endParaRPr lang="en-US" sz="1600" dirty="0"/>
           </a:p>
@@ -4337,21 +4071,21 @@
       </p:sp>
       <p:pic>
         <p:nvPicPr>
-          <p:cNvPr id="14" name="Image 4" descr="готово">    </p:cNvPr>
+          <p:cNvPr id="10" name="Image 2" descr="готово"/>
           <p:cNvPicPr>
             <a:picLocks noChangeAspect="1"/>
           </p:cNvPicPr>
           <p:nvPr/>
         </p:nvPicPr>
         <p:blipFill>
-          <a:blip r:embed="rId5"/>
+          <a:blip r:embed="rId3"/>
           <a:stretch>
             <a:fillRect/>
           </a:stretch>
         </p:blipFill>
         <p:spPr>
           <a:xfrm>
-            <a:off x="914400" y="4709160"/>
+            <a:off x="914400" y="3648456"/>
             <a:ext cx="274320" cy="274320"/>
           </a:xfrm>
           <a:prstGeom prst="rect">
@@ -4361,13 +4095,13 @@
       </p:pic>
       <p:sp>
         <p:nvSpPr>
-          <p:cNvPr id="15" name="Text 7"/>
+          <p:cNvPr id="11" name="Text 5"/>
           <p:cNvSpPr txBox="1"/>
           <p:nvPr/>
         </p:nvSpPr>
         <p:spPr>
           <a:xfrm>
-            <a:off x="1371600" y="4681728"/>
+            <a:off x="1371600" y="3621024"/>
             <a:ext cx="4937760" cy="365760"/>
           </a:xfrm>
           <a:prstGeom prst="rect">
@@ -4380,7 +4114,7 @@
           <a:bodyPr wrap="square" lIns="0" tIns="0" rIns="0" bIns="0" rtlCol="0" anchor="t"/>
           <a:lstStyle/>
           <a:p>
-            <a:pPr indent="0" marL="0">
+            <a:pPr marL="0" indent="0">
               <a:buNone/>
             </a:pPr>
             <a:r>
@@ -4389,7 +4123,7 @@
                   <a:schemeClr val="bg1"/>
                 </a:solidFill>
               </a:rPr>
-              <a:t>Финансы и налоги РК на 2026 год</a:t>
+              <a:t>Telegram-бот: весь путь за один тап</a:t>
             </a:r>
             <a:endParaRPr lang="en-US" sz="1600" dirty="0"/>
           </a:p>
@@ -4397,20 +4131,140 @@
       </p:sp>
       <p:pic>
         <p:nvPicPr>
-          <p:cNvPr id="16" name="Image 5" descr="готово">    </p:cNvPr>
+          <p:cNvPr id="12" name="Image 3" descr="готово"/>
           <p:cNvPicPr>
             <a:picLocks noChangeAspect="1"/>
           </p:cNvPicPr>
           <p:nvPr/>
         </p:nvPicPr>
         <p:blipFill>
-          <a:blip r:embed="rId6"/>
+          <a:blip r:embed="rId3"/>
           <a:stretch>
             <a:fillRect/>
           </a:stretch>
         </p:blipFill>
         <p:spPr>
           <a:xfrm>
+            <a:off x="914400" y="4178808"/>
+            <a:ext cx="274320" cy="274320"/>
+          </a:xfrm>
+          <a:prstGeom prst="rect">
+            <a:avLst/>
+          </a:prstGeom>
+        </p:spPr>
+      </p:pic>
+      <p:sp>
+        <p:nvSpPr>
+          <p:cNvPr id="13" name="Text 6"/>
+          <p:cNvSpPr txBox="1"/>
+          <p:nvPr/>
+        </p:nvSpPr>
+        <p:spPr>
+          <a:xfrm>
+            <a:off x="1371600" y="4151376"/>
+            <a:ext cx="4937760" cy="365760"/>
+          </a:xfrm>
+          <a:prstGeom prst="rect">
+            <a:avLst/>
+          </a:prstGeom>
+          <a:noFill/>
+          <a:ln/>
+        </p:spPr>
+        <p:txBody>
+          <a:bodyPr wrap="square" lIns="0" tIns="0" rIns="0" bIns="0" rtlCol="0" anchor="t"/>
+          <a:lstStyle/>
+          <a:p>
+            <a:pPr marL="0" indent="0">
+              <a:buNone/>
+            </a:pPr>
+            <a:r>
+              <a:rPr lang="en-US" sz="1600" dirty="0">
+                <a:solidFill>
+                  <a:schemeClr val="bg1"/>
+                </a:solidFill>
+              </a:rPr>
+              <a:t>Акт выполненных работ с QR-печатью</a:t>
+            </a:r>
+            <a:endParaRPr lang="en-US" sz="1600" dirty="0"/>
+          </a:p>
+        </p:txBody>
+      </p:sp>
+      <p:pic>
+        <p:nvPicPr>
+          <p:cNvPr id="14" name="Image 4" descr="готово"/>
+          <p:cNvPicPr>
+            <a:picLocks noChangeAspect="1"/>
+          </p:cNvPicPr>
+          <p:nvPr/>
+        </p:nvPicPr>
+        <p:blipFill>
+          <a:blip r:embed="rId3"/>
+          <a:stretch>
+            <a:fillRect/>
+          </a:stretch>
+        </p:blipFill>
+        <p:spPr>
+          <a:xfrm>
+            <a:off x="914400" y="4709160"/>
+            <a:ext cx="274320" cy="274320"/>
+          </a:xfrm>
+          <a:prstGeom prst="rect">
+            <a:avLst/>
+          </a:prstGeom>
+        </p:spPr>
+      </p:pic>
+      <p:sp>
+        <p:nvSpPr>
+          <p:cNvPr id="15" name="Text 7"/>
+          <p:cNvSpPr txBox="1"/>
+          <p:nvPr/>
+        </p:nvSpPr>
+        <p:spPr>
+          <a:xfrm>
+            <a:off x="1371600" y="4681728"/>
+            <a:ext cx="4937760" cy="365760"/>
+          </a:xfrm>
+          <a:prstGeom prst="rect">
+            <a:avLst/>
+          </a:prstGeom>
+          <a:noFill/>
+          <a:ln/>
+        </p:spPr>
+        <p:txBody>
+          <a:bodyPr wrap="square" lIns="0" tIns="0" rIns="0" bIns="0" rtlCol="0" anchor="t"/>
+          <a:lstStyle/>
+          <a:p>
+            <a:pPr marL="0" indent="0">
+              <a:buNone/>
+            </a:pPr>
+            <a:r>
+              <a:rPr lang="en-US" sz="1600" dirty="0">
+                <a:solidFill>
+                  <a:schemeClr val="bg1"/>
+                </a:solidFill>
+              </a:rPr>
+              <a:t>Финансы и налоги РК на 2026 год</a:t>
+            </a:r>
+            <a:endParaRPr lang="en-US" sz="1600" dirty="0"/>
+          </a:p>
+        </p:txBody>
+      </p:sp>
+      <p:pic>
+        <p:nvPicPr>
+          <p:cNvPr id="16" name="Image 5" descr="готово"/>
+          <p:cNvPicPr>
+            <a:picLocks noChangeAspect="1"/>
+          </p:cNvPicPr>
+          <p:nvPr/>
+        </p:nvPicPr>
+        <p:blipFill>
+          <a:blip r:embed="rId3"/>
+          <a:stretch>
+            <a:fillRect/>
+          </a:stretch>
+        </p:blipFill>
+        <p:spPr>
+          <a:xfrm>
             <a:off x="914400" y="5239512"/>
             <a:ext cx="274320" cy="274320"/>
           </a:xfrm>
@@ -4440,7 +4294,7 @@
           <a:bodyPr wrap="square" lIns="0" tIns="0" rIns="0" bIns="0" rtlCol="0" anchor="t"/>
           <a:lstStyle/>
           <a:p>
-            <a:pPr indent="0" marL="0">
+            <a:pPr marL="0" indent="0">
               <a:buNone/>
             </a:pPr>
             <a:r>
@@ -4481,6 +4335,10 @@
             <a:prstDash val="solid"/>
           </a:ln>
         </p:spPr>
+        <p:txBody>
+          <a:bodyPr/>
+          <a:p/>
+        </p:txBody>
       </p:sp>
       <p:sp>
         <p:nvSpPr>
@@ -4503,7 +4361,7 @@
           <a:bodyPr wrap="square" lIns="0" tIns="0" rIns="0" bIns="0" rtlCol="0" anchor="t"/>
           <a:lstStyle/>
           <a:p>
-            <a:pPr indent="0" marL="0">
+            <a:pPr marL="0" indent="0">
               <a:buNone/>
             </a:pPr>
             <a:r>
@@ -4520,14 +4378,14 @@
       </p:sp>
       <p:pic>
         <p:nvPicPr>
-          <p:cNvPr id="20" name="Image 6" descr="дальше">    </p:cNvPr>
+          <p:cNvPr id="20" name="Image 6" descr="дальше"/>
           <p:cNvPicPr>
             <a:picLocks noChangeAspect="1"/>
           </p:cNvPicPr>
           <p:nvPr/>
         </p:nvPicPr>
         <p:blipFill>
-          <a:blip r:embed="rId7"/>
+          <a:blip r:embed="rId4"/>
           <a:stretch>
             <a:fillRect/>
           </a:stretch>
@@ -4563,7 +4421,7 @@
           <a:bodyPr wrap="square" lIns="0" tIns="0" rIns="0" bIns="0" rtlCol="0" anchor="t"/>
           <a:lstStyle/>
           <a:p>
-            <a:pPr indent="0" marL="0">
+            <a:pPr marL="0" indent="0">
               <a:buNone/>
             </a:pPr>
             <a:r>
@@ -4580,14 +4438,14 @@
       </p:sp>
       <p:pic>
         <p:nvPicPr>
-          <p:cNvPr id="22" name="Image 7" descr="дальше">    </p:cNvPr>
+          <p:cNvPr id="22" name="Image 7" descr="дальше"/>
           <p:cNvPicPr>
             <a:picLocks noChangeAspect="1"/>
           </p:cNvPicPr>
           <p:nvPr/>
         </p:nvPicPr>
         <p:blipFill>
-          <a:blip r:embed="rId8"/>
+          <a:blip r:embed="rId4"/>
           <a:stretch>
             <a:fillRect/>
           </a:stretch>
@@ -4623,7 +4481,7 @@
           <a:bodyPr wrap="square" lIns="0" tIns="0" rIns="0" bIns="0" rtlCol="0" anchor="t"/>
           <a:lstStyle/>
           <a:p>
-            <a:pPr indent="0" marL="0">
+            <a:pPr marL="0" indent="0">
               <a:buNone/>
             </a:pPr>
             <a:r>
@@ -4640,14 +4498,14 @@
       </p:sp>
       <p:pic>
         <p:nvPicPr>
-          <p:cNvPr id="24" name="Image 8" descr="дальше">    </p:cNvPr>
+          <p:cNvPr id="24" name="Image 8" descr="дальше"/>
           <p:cNvPicPr>
             <a:picLocks noChangeAspect="1"/>
           </p:cNvPicPr>
           <p:nvPr/>
         </p:nvPicPr>
         <p:blipFill>
-          <a:blip r:embed="rId9"/>
+          <a:blip r:embed="rId4"/>
           <a:stretch>
             <a:fillRect/>
           </a:stretch>
@@ -4683,7 +4541,7 @@
           <a:bodyPr wrap="square" lIns="0" tIns="0" rIns="0" bIns="0" rtlCol="0" anchor="t"/>
           <a:lstStyle/>
           <a:p>
-            <a:pPr indent="0" marL="0">
+            <a:pPr marL="0" indent="0">
               <a:buNone/>
             </a:pPr>
             <a:r>
@@ -4700,14 +4558,14 @@
       </p:sp>
       <p:pic>
         <p:nvPicPr>
-          <p:cNvPr id="26" name="Image 9" descr="дальше">    </p:cNvPr>
+          <p:cNvPr id="26" name="Image 9" descr="дальше"/>
           <p:cNvPicPr>
             <a:picLocks noChangeAspect="1"/>
           </p:cNvPicPr>
           <p:nvPr/>
         </p:nvPicPr>
         <p:blipFill>
-          <a:blip r:embed="rId10"/>
+          <a:blip r:embed="rId4"/>
           <a:stretch>
             <a:fillRect/>
           </a:stretch>
@@ -4743,7 +4601,7 @@
           <a:bodyPr wrap="square" lIns="0" tIns="0" rIns="0" bIns="0" rtlCol="0" anchor="t"/>
           <a:lstStyle/>
           <a:p>
-            <a:pPr indent="0" marL="0">
+            <a:pPr marL="0" indent="0">
               <a:buNone/>
             </a:pPr>
             <a:r>
@@ -4752,7 +4610,7 @@
                   <a:schemeClr val="bg1"/>
                 </a:solidFill>
               </a:rPr>
-              <a:t>Независимый аудит</a:t>
+              <a:t>Заключение юриста и аудит</a:t>
             </a:r>
             <a:endParaRPr lang="en-US" sz="1600" dirty="0"/>
           </a:p>
@@ -4779,7 +4637,7 @@
           <a:bodyPr wrap="square" lIns="0" tIns="0" rIns="0" bIns="0" rtlCol="0" anchor="t"/>
           <a:lstStyle/>
           <a:p>
-            <a:pPr indent="0" marL="0">
+            <a:pPr marL="0" indent="0">
               <a:buNone/>
             </a:pPr>
             <a:r>
@@ -4796,7 +4654,7 @@
       </p:sp>
       <p:sp>
         <p:nvSpPr>
-          <p:cNvPr id="25" name="Slide Number Placeholder 0"/>
+          <p:cNvPr id="3" name="Slide Number Placeholder 0"/>
           <p:cNvSpPr>
             <a:spLocks noGrp="1"/>
           </p:cNvSpPr>
@@ -4814,7 +4672,7 @@
           </a:prstGeom>
           <a:extLst>
             <a:ext uri="{C572A759-6A51-4108-AA02-DFA0A04FC94B}">
-              <ma14:wrappingTextBoxFlag xmlns:ma14="http://schemas.microsoft.com/office/mac/drawingml/2011/main" val="0"/>
+              <ma14:wrappingTextBoxFlag xmlns:ma14="http://schemas.microsoft.com/office/mac/drawingml/2011/main" xmlns="" val="0"/>
             </a:ext>
           </a:extLst>
         </p:spPr>
@@ -4832,7 +4690,7 @@
           <a:p>
             <a:pPr algn="r"/>
             <a:fld id="{F7021451-1387-4CA6-816F-3879F97B5CBC}" type="slidenum">
-              <a:rPr b="0" lang="en-US"/>
+              <a:rPr lang="en-US" b="0"/>
               <a:t>12</a:t>
             </a:fld>
             <a:endParaRPr lang="en-US"/>
@@ -4867,9 +4725,11 @@
       <p:sp>
         <p:nvSpPr>
           <p:cNvPr id="2" name="Text 0"/>
-          <p:cNvSpPr/>
+          <p:cNvSpPr>
+            <a:spLocks noGrp="1"/>
+          </p:cNvSpPr>
           <p:nvPr>
-            <p:ph idx="100" type="title" hasCustomPrompt="1"/>
+            <p:ph type="title" idx="100" hasCustomPrompt="1"/>
           </p:nvPr>
         </p:nvSpPr>
         <p:spPr>
@@ -4887,7 +4747,7 @@
           <a:bodyPr wrap="square" lIns="0" tIns="0" rIns="0" bIns="0" rtlCol="0" anchor="t"/>
           <a:lstStyle/>
           <a:p>
-            <a:pPr algn="l" indent="0" marL="0">
+            <a:pPr marL="0" indent="0" algn="l">
               <a:buNone/>
             </a:pPr>
             <a:r>
@@ -4923,7 +4783,7 @@
           <a:bodyPr wrap="square" lIns="0" tIns="0" rIns="0" bIns="0" rtlCol="0" anchor="t"/>
           <a:lstStyle/>
           <a:p>
-            <a:pPr indent="0" marL="0">
+            <a:pPr marL="0" indent="0">
               <a:buNone/>
             </a:pPr>
             <a:r>
@@ -4959,7 +4819,7 @@
           <a:bodyPr wrap="square" lIns="0" tIns="0" rIns="0" bIns="0" rtlCol="0" anchor="t"/>
           <a:lstStyle/>
           <a:p>
-            <a:pPr indent="0" marL="0">
+            <a:pPr marL="0" indent="0">
               <a:buNone/>
             </a:pPr>
             <a:r>
@@ -4995,7 +4855,7 @@
           <a:bodyPr wrap="square" lIns="0" tIns="0" rIns="0" bIns="0" rtlCol="0" anchor="t"/>
           <a:lstStyle/>
           <a:p>
-            <a:pPr indent="0" marL="0">
+            <a:pPr marL="0" indent="0">
               <a:buNone/>
             </a:pPr>
             <a:r>
@@ -5031,7 +4891,7 @@
           <a:bodyPr wrap="square" lIns="0" tIns="0" rIns="0" bIns="0" rtlCol="0" anchor="t"/>
           <a:lstStyle/>
           <a:p>
-            <a:pPr indent="0" marL="0">
+            <a:pPr marL="0" indent="0">
               <a:buNone/>
             </a:pPr>
             <a:r>
@@ -5075,14 +4935,14 @@
       </p:sp>
       <p:pic>
         <p:nvPicPr>
-          <p:cNvPr id="9" name="Image 0" descr="QR-код: Сайт">    </p:cNvPr>
+          <p:cNvPr id="9" name="Image 0" descr="QR-код: Сайт"/>
           <p:cNvPicPr>
             <a:picLocks noChangeAspect="1"/>
           </p:cNvPicPr>
           <p:nvPr/>
         </p:nvPicPr>
         <p:blipFill>
-          <a:blip r:embed="rId1"/>
+          <a:blip r:embed="rId3"/>
           <a:stretch>
             <a:fillRect/>
           </a:stretch>
@@ -5118,7 +4978,7 @@
           <a:bodyPr wrap="square" lIns="0" tIns="0" rIns="0" bIns="0" rtlCol="0" anchor="t"/>
           <a:lstStyle/>
           <a:p>
-            <a:pPr algn="ctr" indent="0" marL="0">
+            <a:pPr marL="0" indent="0" algn="ctr">
               <a:buNone/>
             </a:pPr>
             <a:r>
@@ -5162,14 +5022,14 @@
       </p:sp>
       <p:pic>
         <p:nvPicPr>
-          <p:cNvPr id="12" name="Image 1" descr="QR-код: Telegram-бот">    </p:cNvPr>
+          <p:cNvPr id="12" name="Image 1" descr="QR-код: Telegram-бот"/>
           <p:cNvPicPr>
             <a:picLocks noChangeAspect="1"/>
           </p:cNvPicPr>
           <p:nvPr/>
         </p:nvPicPr>
         <p:blipFill>
-          <a:blip r:embed="rId2"/>
+          <a:blip r:embed="rId4"/>
           <a:stretch>
             <a:fillRect/>
           </a:stretch>
@@ -5205,7 +5065,7 @@
           <a:bodyPr wrap="square" lIns="0" tIns="0" rIns="0" bIns="0" rtlCol="0" anchor="t"/>
           <a:lstStyle/>
           <a:p>
-            <a:pPr algn="ctr" indent="0" marL="0">
+            <a:pPr marL="0" indent="0" algn="ctr">
               <a:buNone/>
             </a:pPr>
             <a:r>
@@ -5240,7 +5100,7 @@
           </a:prstGeom>
           <a:extLst>
             <a:ext uri="{C572A759-6A51-4108-AA02-DFA0A04FC94B}">
-              <ma14:wrappingTextBoxFlag xmlns:ma14="http://schemas.microsoft.com/office/mac/drawingml/2011/main" val="0"/>
+              <ma14:wrappingTextBoxFlag xmlns:ma14="http://schemas.microsoft.com/office/mac/drawingml/2011/main" xmlns="" val="0"/>
             </a:ext>
           </a:extLst>
         </p:spPr>
@@ -5258,7 +5118,7 @@
           <a:p>
             <a:pPr algn="r"/>
             <a:fld id="{F7021451-1387-4CA6-816F-3879F97B5CBC}" type="slidenum">
-              <a:rPr b="0" lang="en-US"/>
+              <a:rPr lang="en-US" b="0"/>
               <a:t>13</a:t>
             </a:fld>
             <a:endParaRPr lang="en-US"/>
@@ -5293,9 +5153,11 @@
       <p:sp>
         <p:nvSpPr>
           <p:cNvPr id="2" name="Text 0"/>
-          <p:cNvSpPr/>
+          <p:cNvSpPr>
+            <a:spLocks noGrp="1"/>
+          </p:cNvSpPr>
           <p:nvPr>
-            <p:ph idx="100" type="title" hasCustomPrompt="1"/>
+            <p:ph type="title" idx="100" hasCustomPrompt="1"/>
           </p:nvPr>
         </p:nvSpPr>
         <p:spPr>
@@ -5313,7 +5175,7 @@
           <a:bodyPr wrap="square" lIns="0" tIns="0" rIns="0" bIns="0" rtlCol="0" anchor="t"/>
           <a:lstStyle/>
           <a:p>
-            <a:pPr algn="l" indent="0" marL="0">
+            <a:pPr marL="0" indent="0" algn="l">
               <a:buNone/>
             </a:pPr>
             <a:r>
@@ -5382,14 +5244,14 @@
       </p:sp>
       <p:pic>
         <p:nvPicPr>
-          <p:cNvPr id="6" name="Image 0" descr="rocket">    </p:cNvPr>
+          <p:cNvPr id="6" name="Image 0" descr="rocket"/>
           <p:cNvPicPr>
             <a:picLocks noChangeAspect="1"/>
           </p:cNvPicPr>
           <p:nvPr/>
         </p:nvPicPr>
         <p:blipFill>
-          <a:blip r:embed="rId1"/>
+          <a:blip r:embed="rId3"/>
           <a:stretch>
             <a:fillRect/>
           </a:stretch>
@@ -5425,7 +5287,7 @@
           <a:bodyPr wrap="square" lIns="0" tIns="0" rIns="0" bIns="0" rtlCol="0" anchor="t"/>
           <a:lstStyle/>
           <a:p>
-            <a:pPr indent="0" marL="0">
+            <a:pPr marL="0" indent="0">
               <a:buNone/>
             </a:pPr>
             <a:r>
@@ -5461,7 +5323,7 @@
           <a:bodyPr wrap="square" lIns="0" tIns="0" rIns="0" bIns="0" rtlCol="0" anchor="t"/>
           <a:lstStyle/>
           <a:p>
-            <a:pPr indent="0" marL="0">
+            <a:pPr marL="0" indent="0">
               <a:buNone/>
             </a:pPr>
             <a:r>
@@ -5530,14 +5392,14 @@
       </p:sp>
       <p:pic>
         <p:nvPicPr>
-          <p:cNvPr id="11" name="Image 1" descr="search">    </p:cNvPr>
+          <p:cNvPr id="11" name="Image 1" descr="search"/>
           <p:cNvPicPr>
             <a:picLocks noChangeAspect="1"/>
           </p:cNvPicPr>
           <p:nvPr/>
         </p:nvPicPr>
         <p:blipFill>
-          <a:blip r:embed="rId2"/>
+          <a:blip r:embed="rId4"/>
           <a:stretch>
             <a:fillRect/>
           </a:stretch>
@@ -5573,7 +5435,7 @@
           <a:bodyPr wrap="square" lIns="0" tIns="0" rIns="0" bIns="0" rtlCol="0" anchor="t"/>
           <a:lstStyle/>
           <a:p>
-            <a:pPr indent="0" marL="0">
+            <a:pPr marL="0" indent="0">
               <a:buNone/>
             </a:pPr>
             <a:r>
@@ -5609,7 +5471,7 @@
           <a:bodyPr wrap="square" lIns="0" tIns="0" rIns="0" bIns="0" rtlCol="0" anchor="t"/>
           <a:lstStyle/>
           <a:p>
-            <a:pPr indent="0" marL="0">
+            <a:pPr marL="0" indent="0">
               <a:buNone/>
             </a:pPr>
             <a:r>
@@ -5678,14 +5540,14 @@
       </p:sp>
       <p:pic>
         <p:nvPicPr>
-          <p:cNvPr id="16" name="Image 2" descr="wallet">    </p:cNvPr>
+          <p:cNvPr id="16" name="Image 2" descr="wallet"/>
           <p:cNvPicPr>
             <a:picLocks noChangeAspect="1"/>
           </p:cNvPicPr>
           <p:nvPr/>
         </p:nvPicPr>
         <p:blipFill>
-          <a:blip r:embed="rId3"/>
+          <a:blip r:embed="rId5"/>
           <a:stretch>
             <a:fillRect/>
           </a:stretch>
@@ -5721,7 +5583,7 @@
           <a:bodyPr wrap="square" lIns="0" tIns="0" rIns="0" bIns="0" rtlCol="0" anchor="t"/>
           <a:lstStyle/>
           <a:p>
-            <a:pPr indent="0" marL="0">
+            <a:pPr marL="0" indent="0">
               <a:buNone/>
             </a:pPr>
             <a:r>
@@ -5757,7 +5619,7 @@
           <a:bodyPr wrap="square" lIns="0" tIns="0" rIns="0" bIns="0" rtlCol="0" anchor="t"/>
           <a:lstStyle/>
           <a:p>
-            <a:pPr indent="0" marL="0">
+            <a:pPr marL="0" indent="0">
               <a:buNone/>
             </a:pPr>
             <a:r>
@@ -5793,7 +5655,7 @@
           <a:bodyPr wrap="square" lIns="0" tIns="0" rIns="0" bIns="0" rtlCol="0" anchor="t"/>
           <a:lstStyle/>
           <a:p>
-            <a:pPr indent="0" marL="0">
+            <a:pPr marL="0" indent="0">
               <a:buNone/>
             </a:pPr>
             <a:r>
@@ -5828,7 +5690,7 @@
           </a:prstGeom>
           <a:extLst>
             <a:ext uri="{C572A759-6A51-4108-AA02-DFA0A04FC94B}">
-              <ma14:wrappingTextBoxFlag xmlns:ma14="http://schemas.microsoft.com/office/mac/drawingml/2011/main" val="0"/>
+              <ma14:wrappingTextBoxFlag xmlns:ma14="http://schemas.microsoft.com/office/mac/drawingml/2011/main" xmlns="" val="0"/>
             </a:ext>
           </a:extLst>
         </p:spPr>
@@ -5846,7 +5708,7 @@
           <a:p>
             <a:pPr algn="r"/>
             <a:fld id="{F7021451-1387-4CA6-816F-3879F97B5CBC}" type="slidenum">
-              <a:rPr b="0" lang="en-US"/>
+              <a:rPr lang="en-US" b="0"/>
               <a:t>2</a:t>
             </a:fld>
             <a:endParaRPr lang="en-US"/>
@@ -5881,9 +5743,11 @@
       <p:sp>
         <p:nvSpPr>
           <p:cNvPr id="2" name="Text 0"/>
-          <p:cNvSpPr/>
+          <p:cNvSpPr>
+            <a:spLocks noGrp="1"/>
+          </p:cNvSpPr>
           <p:nvPr>
-            <p:ph idx="100" type="title" hasCustomPrompt="1"/>
+            <p:ph type="title" idx="100" hasCustomPrompt="1"/>
           </p:nvPr>
         </p:nvSpPr>
         <p:spPr>
@@ -5901,7 +5765,7 @@
           <a:bodyPr wrap="square" lIns="0" tIns="0" rIns="0" bIns="0" rtlCol="0" anchor="t"/>
           <a:lstStyle/>
           <a:p>
-            <a:pPr algn="l" indent="0" marL="0">
+            <a:pPr marL="0" indent="0" algn="l">
               <a:buNone/>
             </a:pPr>
             <a:r>
@@ -5942,6 +5806,10 @@
             <a:prstDash val="solid"/>
           </a:ln>
         </p:spPr>
+        <p:txBody>
+          <a:bodyPr/>
+          <a:p/>
+        </p:txBody>
       </p:sp>
       <p:sp>
         <p:nvSpPr>
@@ -5967,17 +5835,21 @@
             <a:prstDash val="solid"/>
           </a:ln>
         </p:spPr>
+        <p:txBody>
+          <a:bodyPr/>
+          <a:p/>
+        </p:txBody>
       </p:sp>
       <p:pic>
         <p:nvPicPr>
-          <p:cNvPr id="6" name="Image 0" descr="users">    </p:cNvPr>
+          <p:cNvPr id="6" name="Image 0" descr="users"/>
           <p:cNvPicPr>
             <a:picLocks noChangeAspect="1"/>
           </p:cNvPicPr>
           <p:nvPr/>
         </p:nvPicPr>
         <p:blipFill>
-          <a:blip r:embed="rId1"/>
+          <a:blip r:embed="rId3"/>
           <a:stretch>
             <a:fillRect/>
           </a:stretch>
@@ -6013,7 +5885,7 @@
           <a:bodyPr wrap="square" lIns="0" tIns="0" rIns="0" bIns="0" rtlCol="0" anchor="t"/>
           <a:lstStyle/>
           <a:p>
-            <a:pPr indent="0" marL="0">
+            <a:pPr marL="0" indent="0">
               <a:buNone/>
             </a:pPr>
             <a:r>
@@ -6049,7 +5921,7 @@
           <a:bodyPr wrap="square" lIns="0" tIns="0" rIns="0" bIns="0" rtlCol="0" anchor="t"/>
           <a:lstStyle/>
           <a:p>
-            <a:pPr indent="0" marL="0">
+            <a:pPr marL="0" indent="0">
               <a:buNone/>
             </a:pPr>
             <a:r>
@@ -6090,6 +5962,10 @@
             <a:prstDash val="solid"/>
           </a:ln>
         </p:spPr>
+        <p:txBody>
+          <a:bodyPr/>
+          <a:p/>
+        </p:txBody>
       </p:sp>
       <p:sp>
         <p:nvSpPr>
@@ -6115,17 +5991,21 @@
             <a:prstDash val="solid"/>
           </a:ln>
         </p:spPr>
+        <p:txBody>
+          <a:bodyPr/>
+          <a:p/>
+        </p:txBody>
       </p:sp>
       <p:pic>
         <p:nvPicPr>
-          <p:cNvPr id="11" name="Image 1" descr="bell">    </p:cNvPr>
+          <p:cNvPr id="11" name="Image 1" descr="bell"/>
           <p:cNvPicPr>
             <a:picLocks noChangeAspect="1"/>
           </p:cNvPicPr>
           <p:nvPr/>
         </p:nvPicPr>
         <p:blipFill>
-          <a:blip r:embed="rId2"/>
+          <a:blip r:embed="rId4"/>
           <a:stretch>
             <a:fillRect/>
           </a:stretch>
@@ -6161,7 +6041,7 @@
           <a:bodyPr wrap="square" lIns="0" tIns="0" rIns="0" bIns="0" rtlCol="0" anchor="t"/>
           <a:lstStyle/>
           <a:p>
-            <a:pPr indent="0" marL="0">
+            <a:pPr marL="0" indent="0">
               <a:buNone/>
             </a:pPr>
             <a:r>
@@ -6197,7 +6077,7 @@
           <a:bodyPr wrap="square" lIns="0" tIns="0" rIns="0" bIns="0" rtlCol="0" anchor="t"/>
           <a:lstStyle/>
           <a:p>
-            <a:pPr indent="0" marL="0">
+            <a:pPr marL="0" indent="0">
               <a:buNone/>
             </a:pPr>
             <a:r>
@@ -6238,6 +6118,10 @@
             <a:prstDash val="solid"/>
           </a:ln>
         </p:spPr>
+        <p:txBody>
+          <a:bodyPr/>
+          <a:p/>
+        </p:txBody>
       </p:sp>
       <p:sp>
         <p:nvSpPr>
@@ -6263,17 +6147,21 @@
             <a:prstDash val="solid"/>
           </a:ln>
         </p:spPr>
+        <p:txBody>
+          <a:bodyPr/>
+          <a:p/>
+        </p:txBody>
       </p:sp>
       <p:pic>
         <p:nvPicPr>
-          <p:cNvPr id="16" name="Image 2" descr="file">    </p:cNvPr>
+          <p:cNvPr id="16" name="Image 2" descr="file"/>
           <p:cNvPicPr>
             <a:picLocks noChangeAspect="1"/>
           </p:cNvPicPr>
           <p:nvPr/>
         </p:nvPicPr>
         <p:blipFill>
-          <a:blip r:embed="rId3"/>
+          <a:blip r:embed="rId5"/>
           <a:stretch>
             <a:fillRect/>
           </a:stretch>
@@ -6309,7 +6197,7 @@
           <a:bodyPr wrap="square" lIns="0" tIns="0" rIns="0" bIns="0" rtlCol="0" anchor="t"/>
           <a:lstStyle/>
           <a:p>
-            <a:pPr indent="0" marL="0">
+            <a:pPr marL="0" indent="0">
               <a:buNone/>
             </a:pPr>
             <a:r>
@@ -6345,7 +6233,7 @@
           <a:bodyPr wrap="square" lIns="0" tIns="0" rIns="0" bIns="0" rtlCol="0" anchor="t"/>
           <a:lstStyle/>
           <a:p>
-            <a:pPr indent="0" marL="0">
+            <a:pPr marL="0" indent="0">
               <a:buNone/>
             </a:pPr>
             <a:r>
@@ -6354,7 +6242,7 @@
                   <a:schemeClr val="bg2"/>
                 </a:solidFill>
               </a:rPr>
-              <a:t>Есть скриншот транзакции, но нет документа, который примет бухгалтер</a:t>
+              <a:t>Есть скриншот транзакции, но нет акта для бухгалтера</a:t>
             </a:r>
             <a:endParaRPr lang="en-US" sz="1600" dirty="0"/>
           </a:p>
@@ -6386,6 +6274,10 @@
             <a:prstDash val="solid"/>
           </a:ln>
         </p:spPr>
+        <p:txBody>
+          <a:bodyPr/>
+          <a:p/>
+        </p:txBody>
       </p:sp>
       <p:sp>
         <p:nvSpPr>
@@ -6411,17 +6303,21 @@
             <a:prstDash val="solid"/>
           </a:ln>
         </p:spPr>
+        <p:txBody>
+          <a:bodyPr/>
+          <a:p/>
+        </p:txBody>
       </p:sp>
       <p:pic>
         <p:nvPicPr>
-          <p:cNvPr id="21" name="Image 3" descr="calc">    </p:cNvPr>
+          <p:cNvPr id="21" name="Image 3" descr="calc"/>
           <p:cNvPicPr>
             <a:picLocks noChangeAspect="1"/>
           </p:cNvPicPr>
           <p:nvPr/>
         </p:nvPicPr>
         <p:blipFill>
-          <a:blip r:embed="rId4"/>
+          <a:blip r:embed="rId6"/>
           <a:stretch>
             <a:fillRect/>
           </a:stretch>
@@ -6457,7 +6353,7 @@
           <a:bodyPr wrap="square" lIns="0" tIns="0" rIns="0" bIns="0" rtlCol="0" anchor="t"/>
           <a:lstStyle/>
           <a:p>
-            <a:pPr indent="0" marL="0">
+            <a:pPr marL="0" indent="0">
               <a:buNone/>
             </a:pPr>
             <a:r>
@@ -6493,7 +6389,7 @@
           <a:bodyPr wrap="square" lIns="0" tIns="0" rIns="0" bIns="0" rtlCol="0" anchor="t"/>
           <a:lstStyle/>
           <a:p>
-            <a:pPr indent="0" marL="0">
+            <a:pPr marL="0" indent="0">
               <a:buNone/>
             </a:pPr>
             <a:r>
@@ -6528,7 +6424,7 @@
           </a:prstGeom>
           <a:extLst>
             <a:ext uri="{C572A759-6A51-4108-AA02-DFA0A04FC94B}">
-              <ma14:wrappingTextBoxFlag xmlns:ma14="http://schemas.microsoft.com/office/mac/drawingml/2011/main" val="0"/>
+              <ma14:wrappingTextBoxFlag xmlns:ma14="http://schemas.microsoft.com/office/mac/drawingml/2011/main" xmlns="" val="0"/>
             </a:ext>
           </a:extLst>
         </p:spPr>
@@ -6546,7 +6442,7 @@
           <a:p>
             <a:pPr algn="r"/>
             <a:fld id="{F7021451-1387-4CA6-816F-3879F97B5CBC}" type="slidenum">
-              <a:rPr b="0" lang="en-US"/>
+              <a:rPr lang="en-US" b="0"/>
               <a:t>3</a:t>
             </a:fld>
             <a:endParaRPr lang="en-US"/>
@@ -6581,9 +6477,11 @@
       <p:sp>
         <p:nvSpPr>
           <p:cNvPr id="2" name="Text 0"/>
-          <p:cNvSpPr/>
+          <p:cNvSpPr>
+            <a:spLocks noGrp="1"/>
+          </p:cNvSpPr>
           <p:nvPr>
-            <p:ph idx="100" type="title" hasCustomPrompt="1"/>
+            <p:ph type="title" idx="100" hasCustomPrompt="1"/>
           </p:nvPr>
         </p:nvSpPr>
         <p:spPr>
@@ -6601,7 +6499,7 @@
           <a:bodyPr wrap="square" lIns="0" tIns="0" rIns="0" bIns="0" rtlCol="0" anchor="t"/>
           <a:lstStyle/>
           <a:p>
-            <a:pPr algn="l" indent="0" marL="0">
+            <a:pPr marL="0" indent="0" algn="l">
               <a:buNone/>
             </a:pPr>
             <a:r>
@@ -6664,7 +6562,7 @@
           <a:bodyPr wrap="square" lIns="0" tIns="0" rIns="0" bIns="0" rtlCol="0" anchor="t"/>
           <a:lstStyle/>
           <a:p>
-            <a:pPr indent="0" marL="0">
+            <a:pPr marL="0" indent="0">
               <a:buNone/>
             </a:pPr>
             <a:r>
@@ -6700,7 +6598,7 @@
           <a:bodyPr wrap="square" lIns="0" tIns="0" rIns="0" bIns="0" rtlCol="0" anchor="t"/>
           <a:lstStyle/>
           <a:p>
-            <a:pPr indent="0" marL="0">
+            <a:pPr marL="0" indent="0">
               <a:buNone/>
             </a:pPr>
             <a:r>
@@ -6736,7 +6634,7 @@
           <a:bodyPr wrap="square" lIns="0" tIns="0" rIns="0" bIns="0" rtlCol="0" anchor="t"/>
           <a:lstStyle/>
           <a:p>
-            <a:pPr indent="0" marL="0">
+            <a:pPr marL="0" indent="0">
               <a:buNone/>
             </a:pPr>
             <a:r>
@@ -6799,7 +6697,7 @@
           <a:bodyPr wrap="square" lIns="0" tIns="0" rIns="0" bIns="0" rtlCol="0" anchor="t"/>
           <a:lstStyle/>
           <a:p>
-            <a:pPr indent="0" marL="0">
+            <a:pPr marL="0" indent="0">
               <a:buNone/>
             </a:pPr>
             <a:r>
@@ -6835,7 +6733,7 @@
           <a:bodyPr wrap="square" lIns="0" tIns="0" rIns="0" bIns="0" rtlCol="0" anchor="t"/>
           <a:lstStyle/>
           <a:p>
-            <a:pPr indent="0" marL="0">
+            <a:pPr marL="0" indent="0">
               <a:buNone/>
             </a:pPr>
             <a:r>
@@ -6871,7 +6769,7 @@
           <a:bodyPr wrap="square" lIns="0" tIns="0" rIns="0" bIns="0" rtlCol="0" anchor="t"/>
           <a:lstStyle/>
           <a:p>
-            <a:pPr indent="0" marL="0">
+            <a:pPr marL="0" indent="0">
               <a:buNone/>
             </a:pPr>
             <a:r>
@@ -6907,7 +6805,7 @@
           <a:bodyPr wrap="square" lIns="0" tIns="0" rIns="0" bIns="0" rtlCol="0" anchor="t"/>
           <a:lstStyle/>
           <a:p>
-            <a:pPr indent="0" marL="0">
+            <a:pPr marL="0" indent="0">
               <a:buNone/>
             </a:pPr>
             <a:r>
@@ -6943,7 +6841,7 @@
           <a:bodyPr wrap="square" lIns="0" tIns="0" rIns="0" bIns="0" rtlCol="0" anchor="t"/>
           <a:lstStyle/>
           <a:p>
-            <a:pPr indent="0" marL="0">
+            <a:pPr marL="0" indent="0">
               <a:buNone/>
             </a:pPr>
             <a:r>
@@ -6978,7 +6876,7 @@
           </a:prstGeom>
           <a:extLst>
             <a:ext uri="{C572A759-6A51-4108-AA02-DFA0A04FC94B}">
-              <ma14:wrappingTextBoxFlag xmlns:ma14="http://schemas.microsoft.com/office/mac/drawingml/2011/main" val="0"/>
+              <ma14:wrappingTextBoxFlag xmlns:ma14="http://schemas.microsoft.com/office/mac/drawingml/2011/main" xmlns="" val="0"/>
             </a:ext>
           </a:extLst>
         </p:spPr>
@@ -6996,7 +6894,7 @@
           <a:p>
             <a:pPr algn="r"/>
             <a:fld id="{F7021451-1387-4CA6-816F-3879F97B5CBC}" type="slidenum">
-              <a:rPr b="0" lang="en-US"/>
+              <a:rPr lang="en-US" b="0"/>
               <a:t>4</a:t>
             </a:fld>
             <a:endParaRPr lang="en-US"/>
@@ -7031,9 +6929,11 @@
       <p:sp>
         <p:nvSpPr>
           <p:cNvPr id="2" name="Text 0"/>
-          <p:cNvSpPr/>
+          <p:cNvSpPr>
+            <a:spLocks noGrp="1"/>
+          </p:cNvSpPr>
           <p:nvPr>
-            <p:ph idx="100" type="title" hasCustomPrompt="1"/>
+            <p:ph type="title" idx="100" hasCustomPrompt="1"/>
           </p:nvPr>
         </p:nvSpPr>
         <p:spPr>
@@ -7051,7 +6951,7 @@
           <a:bodyPr wrap="square" lIns="0" tIns="0" rIns="0" bIns="0" rtlCol="0" anchor="t"/>
           <a:lstStyle/>
           <a:p>
-            <a:pPr algn="l" indent="0" marL="0">
+            <a:pPr marL="0" indent="0" algn="l">
               <a:buNone/>
             </a:pPr>
             <a:r>
@@ -7082,16 +6982,34 @@
         </p:nvGraphicFramePr>
         <p:xfrm>
           <a:off x="548640" y="1645920"/>
-          <a:ext cx="11094415" cy="914400"/>
+          <a:ext cx="11094415" cy="4114800"/>
         </p:xfrm>
         <a:graphic>
           <a:graphicData uri="http://schemas.openxmlformats.org/drawingml/2006/table">
             <a:tbl>
               <a:tblPr/>
               <a:tblGrid>
-                <a:gridCol w="2651760"/>
-                <a:gridCol w="4023360"/>
-                <a:gridCol w="4419295"/>
+                <a:gridCol w="2651760">
+                  <a:extLst>
+                    <a:ext uri="{9D8B030D-6E8A-4147-A177-3AD203B41FA5}">
+                      <a16:colId xmlns:a16="http://schemas.microsoft.com/office/drawing/2014/main" val="20000"/>
+                    </a:ext>
+                  </a:extLst>
+                </a:gridCol>
+                <a:gridCol w="4023360">
+                  <a:extLst>
+                    <a:ext uri="{9D8B030D-6E8A-4147-A177-3AD203B41FA5}">
+                      <a16:colId xmlns:a16="http://schemas.microsoft.com/office/drawing/2014/main" val="20001"/>
+                    </a:ext>
+                  </a:extLst>
+                </a:gridCol>
+                <a:gridCol w="4419295">
+                  <a:extLst>
+                    <a:ext uri="{9D8B030D-6E8A-4147-A177-3AD203B41FA5}">
+                      <a16:colId xmlns:a16="http://schemas.microsoft.com/office/drawing/2014/main" val="20002"/>
+                    </a:ext>
+                  </a:extLst>
+                </a:gridCol>
               </a:tblGrid>
               <a:tr h="548640">
                 <a:tc>
@@ -7099,13 +7017,13 @@
                     <a:bodyPr/>
                     <a:lstStyle/>
                     <a:p>
-                      <a:pPr indent="0" marL="0">
+                      <a:pPr marL="0" indent="0">
                         <a:buNone/>
                       </a:pPr>
                       <a:endParaRPr lang="en-US" sz="1600" dirty="0"/>
                     </a:p>
                   </a:txBody>
-                  <a:tcPr marL="182880" marR="182880" marT="45720" marB="45720" anchor="ctr">
+                  <a:tcPr marL="182880" marR="182880" anchor="ctr">
                     <a:lnL w="9525" cap="flat" cmpd="sng" algn="ctr">
                       <a:solidFill>
                         <a:srgbClr val="262C34"/>
@@ -7152,7 +7070,7 @@
                     <a:bodyPr/>
                     <a:lstStyle/>
                     <a:p>
-                      <a:pPr indent="0" marL="0">
+                      <a:pPr marL="0" indent="0">
                         <a:buNone/>
                       </a:pPr>
                       <a:r>
@@ -7166,7 +7084,7 @@
                       <a:endParaRPr lang="en-US" sz="1600" dirty="0"/>
                     </a:p>
                   </a:txBody>
-                  <a:tcPr marL="182880" marR="182880" marT="45720" marB="45720" anchor="ctr">
+                  <a:tcPr marL="182880" marR="182880" anchor="ctr">
                     <a:lnL w="9525" cap="flat" cmpd="sng" algn="ctr">
                       <a:solidFill>
                         <a:srgbClr val="262C34"/>
@@ -7213,7 +7131,7 @@
                     <a:bodyPr/>
                     <a:lstStyle/>
                     <a:p>
-                      <a:pPr indent="0" marL="0">
+                      <a:pPr marL="0" indent="0">
                         <a:buNone/>
                       </a:pPr>
                       <a:r>
@@ -7227,7 +7145,7 @@
                       <a:endParaRPr lang="en-US" sz="1600" dirty="0"/>
                     </a:p>
                   </a:txBody>
-                  <a:tcPr marL="182880" marR="182880" marT="45720" marB="45720" anchor="ctr">
+                  <a:tcPr marL="182880" marR="182880" anchor="ctr">
                     <a:lnL w="9525" cap="flat" cmpd="sng" algn="ctr">
                       <a:solidFill>
                         <a:srgbClr val="262C34"/>
@@ -7269,6 +7187,11 @@
                     </a:solidFill>
                   </a:tcPr>
                 </a:tc>
+                <a:extLst>
+                  <a:ext uri="{0D108BD9-81ED-4DB2-BD59-A6C34878D82A}">
+                    <a16:rowId xmlns:a16="http://schemas.microsoft.com/office/drawing/2014/main" val="10000"/>
+                  </a:ext>
+                </a:extLst>
               </a:tr>
               <a:tr h="713232">
                 <a:tc>
@@ -7276,7 +7199,7 @@
                     <a:bodyPr/>
                     <a:lstStyle/>
                     <a:p>
-                      <a:pPr indent="0" marL="0">
+                      <a:pPr marL="0" indent="0">
                         <a:buNone/>
                       </a:pPr>
                       <a:r>
@@ -7290,7 +7213,7 @@
                       <a:endParaRPr lang="en-US" sz="1600" dirty="0"/>
                     </a:p>
                   </a:txBody>
-                  <a:tcPr marL="182880" marR="182880" marT="45720" marB="45720" anchor="ctr">
+                  <a:tcPr marL="182880" marR="182880" anchor="ctr">
                     <a:lnL w="9525" cap="flat" cmpd="sng" algn="ctr">
                       <a:solidFill>
                         <a:srgbClr val="262C34"/>
@@ -7337,7 +7260,7 @@
                     <a:bodyPr/>
                     <a:lstStyle/>
                     <a:p>
-                      <a:pPr indent="0" marL="0">
+                      <a:pPr marL="0" indent="0">
                         <a:buNone/>
                       </a:pPr>
                       <a:r>
@@ -7351,7 +7274,7 @@
                       <a:endParaRPr lang="en-US" sz="1600" dirty="0"/>
                     </a:p>
                   </a:txBody>
-                  <a:tcPr marL="182880" marR="182880" marT="45720" marB="45720" anchor="ctr">
+                  <a:tcPr marL="182880" marR="182880" anchor="ctr">
                     <a:lnL w="9525" cap="flat" cmpd="sng" algn="ctr">
                       <a:solidFill>
                         <a:srgbClr val="262C34"/>
@@ -7398,7 +7321,7 @@
                     <a:bodyPr/>
                     <a:lstStyle/>
                     <a:p>
-                      <a:pPr indent="0" marL="0">
+                      <a:pPr marL="0" indent="0">
                         <a:buNone/>
                       </a:pPr>
                       <a:r>
@@ -7412,7 +7335,7 @@
                       <a:endParaRPr lang="en-US" sz="1600" dirty="0"/>
                     </a:p>
                   </a:txBody>
-                  <a:tcPr marL="182880" marR="182880" marT="45720" marB="45720" anchor="ctr">
+                  <a:tcPr marL="182880" marR="182880" anchor="ctr">
                     <a:lnL w="9525" cap="flat" cmpd="sng" algn="ctr">
                       <a:solidFill>
                         <a:srgbClr val="262C34"/>
@@ -7454,6 +7377,11 @@
                     </a:solidFill>
                   </a:tcPr>
                 </a:tc>
+                <a:extLst>
+                  <a:ext uri="{0D108BD9-81ED-4DB2-BD59-A6C34878D82A}">
+                    <a16:rowId xmlns:a16="http://schemas.microsoft.com/office/drawing/2014/main" val="10001"/>
+                  </a:ext>
+                </a:extLst>
               </a:tr>
               <a:tr h="713232">
                 <a:tc>
@@ -7461,7 +7389,7 @@
                     <a:bodyPr/>
                     <a:lstStyle/>
                     <a:p>
-                      <a:pPr indent="0" marL="0">
+                      <a:pPr marL="0" indent="0">
                         <a:buNone/>
                       </a:pPr>
                       <a:r>
@@ -7475,7 +7403,7 @@
                       <a:endParaRPr lang="en-US" sz="1600" dirty="0"/>
                     </a:p>
                   </a:txBody>
-                  <a:tcPr marL="182880" marR="182880" marT="45720" marB="45720" anchor="ctr">
+                  <a:tcPr marL="182880" marR="182880" anchor="ctr">
                     <a:lnL w="9525" cap="flat" cmpd="sng" algn="ctr">
                       <a:solidFill>
                         <a:srgbClr val="262C34"/>
@@ -7522,7 +7450,7 @@
                     <a:bodyPr/>
                     <a:lstStyle/>
                     <a:p>
-                      <a:pPr indent="0" marL="0">
+                      <a:pPr marL="0" indent="0">
                         <a:buNone/>
                       </a:pPr>
                       <a:r>
@@ -7536,7 +7464,7 @@
                       <a:endParaRPr lang="en-US" sz="1600" dirty="0"/>
                     </a:p>
                   </a:txBody>
-                  <a:tcPr marL="182880" marR="182880" marT="45720" marB="45720" anchor="ctr">
+                  <a:tcPr marL="182880" marR="182880" anchor="ctr">
                     <a:lnL w="9525" cap="flat" cmpd="sng" algn="ctr">
                       <a:solidFill>
                         <a:srgbClr val="262C34"/>
@@ -7583,7 +7511,7 @@
                     <a:bodyPr/>
                     <a:lstStyle/>
                     <a:p>
-                      <a:pPr indent="0" marL="0">
+                      <a:pPr marL="0" indent="0">
                         <a:buNone/>
                       </a:pPr>
                       <a:r>
@@ -7597,7 +7525,7 @@
                       <a:endParaRPr lang="en-US" sz="1600" dirty="0"/>
                     </a:p>
                   </a:txBody>
-                  <a:tcPr marL="182880" marR="182880" marT="45720" marB="45720" anchor="ctr">
+                  <a:tcPr marL="182880" marR="182880" anchor="ctr">
                     <a:lnL w="9525" cap="flat" cmpd="sng" algn="ctr">
                       <a:solidFill>
                         <a:srgbClr val="262C34"/>
@@ -7639,6 +7567,11 @@
                     </a:solidFill>
                   </a:tcPr>
                 </a:tc>
+                <a:extLst>
+                  <a:ext uri="{0D108BD9-81ED-4DB2-BD59-A6C34878D82A}">
+                    <a16:rowId xmlns:a16="http://schemas.microsoft.com/office/drawing/2014/main" val="10002"/>
+                  </a:ext>
+                </a:extLst>
               </a:tr>
               <a:tr h="713232">
                 <a:tc>
@@ -7646,7 +7579,7 @@
                     <a:bodyPr/>
                     <a:lstStyle/>
                     <a:p>
-                      <a:pPr indent="0" marL="0">
+                      <a:pPr marL="0" indent="0">
                         <a:buNone/>
                       </a:pPr>
                       <a:r>
@@ -7660,7 +7593,7 @@
                       <a:endParaRPr lang="en-US" sz="1600" dirty="0"/>
                     </a:p>
                   </a:txBody>
-                  <a:tcPr marL="182880" marR="182880" marT="45720" marB="45720" anchor="ctr">
+                  <a:tcPr marL="182880" marR="182880" anchor="ctr">
                     <a:lnL w="9525" cap="flat" cmpd="sng" algn="ctr">
                       <a:solidFill>
                         <a:srgbClr val="262C34"/>
@@ -7707,7 +7640,7 @@
                     <a:bodyPr/>
                     <a:lstStyle/>
                     <a:p>
-                      <a:pPr indent="0" marL="0">
+                      <a:pPr marL="0" indent="0">
                         <a:buNone/>
                       </a:pPr>
                       <a:r>
@@ -7721,7 +7654,7 @@
                       <a:endParaRPr lang="en-US" sz="1600" dirty="0"/>
                     </a:p>
                   </a:txBody>
-                  <a:tcPr marL="182880" marR="182880" marT="45720" marB="45720" anchor="ctr">
+                  <a:tcPr marL="182880" marR="182880" anchor="ctr">
                     <a:lnL w="9525" cap="flat" cmpd="sng" algn="ctr">
                       <a:solidFill>
                         <a:srgbClr val="262C34"/>
@@ -7768,7 +7701,7 @@
                     <a:bodyPr/>
                     <a:lstStyle/>
                     <a:p>
-                      <a:pPr indent="0" marL="0">
+                      <a:pPr marL="0" indent="0">
                         <a:buNone/>
                       </a:pPr>
                       <a:r>
@@ -7782,7 +7715,7 @@
                       <a:endParaRPr lang="en-US" sz="1600" dirty="0"/>
                     </a:p>
                   </a:txBody>
-                  <a:tcPr marL="182880" marR="182880" marT="45720" marB="45720" anchor="ctr">
+                  <a:tcPr marL="182880" marR="182880" anchor="ctr">
                     <a:lnL w="9525" cap="flat" cmpd="sng" algn="ctr">
                       <a:solidFill>
                         <a:srgbClr val="262C34"/>
@@ -7824,6 +7757,11 @@
                     </a:solidFill>
                   </a:tcPr>
                 </a:tc>
+                <a:extLst>
+                  <a:ext uri="{0D108BD9-81ED-4DB2-BD59-A6C34878D82A}">
+                    <a16:rowId xmlns:a16="http://schemas.microsoft.com/office/drawing/2014/main" val="10003"/>
+                  </a:ext>
+                </a:extLst>
               </a:tr>
               <a:tr h="713232">
                 <a:tc>
@@ -7831,7 +7769,7 @@
                     <a:bodyPr/>
                     <a:lstStyle/>
                     <a:p>
-                      <a:pPr indent="0" marL="0">
+                      <a:pPr marL="0" indent="0">
                         <a:buNone/>
                       </a:pPr>
                       <a:r>
@@ -7845,7 +7783,7 @@
                       <a:endParaRPr lang="en-US" sz="1600" dirty="0"/>
                     </a:p>
                   </a:txBody>
-                  <a:tcPr marL="182880" marR="182880" marT="45720" marB="45720" anchor="ctr">
+                  <a:tcPr marL="182880" marR="182880" anchor="ctr">
                     <a:lnL w="9525" cap="flat" cmpd="sng" algn="ctr">
                       <a:solidFill>
                         <a:srgbClr val="262C34"/>
@@ -7892,7 +7830,7 @@
                     <a:bodyPr/>
                     <a:lstStyle/>
                     <a:p>
-                      <a:pPr indent="0" marL="0">
+                      <a:pPr marL="0" indent="0">
                         <a:buNone/>
                       </a:pPr>
                       <a:r>
@@ -7906,7 +7844,7 @@
                       <a:endParaRPr lang="en-US" sz="1600" dirty="0"/>
                     </a:p>
                   </a:txBody>
-                  <a:tcPr marL="182880" marR="182880" marT="45720" marB="45720" anchor="ctr">
+                  <a:tcPr marL="182880" marR="182880" anchor="ctr">
                     <a:lnL w="9525" cap="flat" cmpd="sng" algn="ctr">
                       <a:solidFill>
                         <a:srgbClr val="262C34"/>
@@ -7953,7 +7891,7 @@
                     <a:bodyPr/>
                     <a:lstStyle/>
                     <a:p>
-                      <a:pPr indent="0" marL="0">
+                      <a:pPr marL="0" indent="0">
                         <a:buNone/>
                       </a:pPr>
                       <a:r>
@@ -7967,7 +7905,7 @@
                       <a:endParaRPr lang="en-US" sz="1600" dirty="0"/>
                     </a:p>
                   </a:txBody>
-                  <a:tcPr marL="182880" marR="182880" marT="45720" marB="45720" anchor="ctr">
+                  <a:tcPr marL="182880" marR="182880" anchor="ctr">
                     <a:lnL w="9525" cap="flat" cmpd="sng" algn="ctr">
                       <a:solidFill>
                         <a:srgbClr val="262C34"/>
@@ -8009,6 +7947,11 @@
                     </a:solidFill>
                   </a:tcPr>
                 </a:tc>
+                <a:extLst>
+                  <a:ext uri="{0D108BD9-81ED-4DB2-BD59-A6C34878D82A}">
+                    <a16:rowId xmlns:a16="http://schemas.microsoft.com/office/drawing/2014/main" val="10004"/>
+                  </a:ext>
+                </a:extLst>
               </a:tr>
               <a:tr h="713232">
                 <a:tc>
@@ -8016,7 +7959,7 @@
                     <a:bodyPr/>
                     <a:lstStyle/>
                     <a:p>
-                      <a:pPr indent="0" marL="0">
+                      <a:pPr marL="0" indent="0">
                         <a:buNone/>
                       </a:pPr>
                       <a:r>
@@ -8030,7 +7973,7 @@
                       <a:endParaRPr lang="en-US" sz="1600" dirty="0"/>
                     </a:p>
                   </a:txBody>
-                  <a:tcPr marL="182880" marR="182880" marT="45720" marB="45720" anchor="ctr">
+                  <a:tcPr marL="182880" marR="182880" anchor="ctr">
                     <a:lnL w="9525" cap="flat" cmpd="sng" algn="ctr">
                       <a:solidFill>
                         <a:srgbClr val="262C34"/>
@@ -8077,7 +8020,7 @@
                     <a:bodyPr/>
                     <a:lstStyle/>
                     <a:p>
-                      <a:pPr indent="0" marL="0">
+                      <a:pPr marL="0" indent="0">
                         <a:buNone/>
                       </a:pPr>
                       <a:r>
@@ -8091,7 +8034,7 @@
                       <a:endParaRPr lang="en-US" sz="1600" dirty="0"/>
                     </a:p>
                   </a:txBody>
-                  <a:tcPr marL="182880" marR="182880" marT="45720" marB="45720" anchor="ctr">
+                  <a:tcPr marL="182880" marR="182880" anchor="ctr">
                     <a:lnL w="9525" cap="flat" cmpd="sng" algn="ctr">
                       <a:solidFill>
                         <a:srgbClr val="262C34"/>
@@ -8138,7 +8081,7 @@
                     <a:bodyPr/>
                     <a:lstStyle/>
                     <a:p>
-                      <a:pPr indent="0" marL="0">
+                      <a:pPr marL="0" indent="0">
                         <a:buNone/>
                       </a:pPr>
                       <a:r>
@@ -8152,7 +8095,7 @@
                       <a:endParaRPr lang="en-US" sz="1600" dirty="0"/>
                     </a:p>
                   </a:txBody>
-                  <a:tcPr marL="182880" marR="182880" marT="45720" marB="45720" anchor="ctr">
+                  <a:tcPr marL="182880" marR="182880" anchor="ctr">
                     <a:lnL w="9525" cap="flat" cmpd="sng" algn="ctr">
                       <a:solidFill>
                         <a:srgbClr val="262C34"/>
@@ -8194,6 +8137,11 @@
                     </a:solidFill>
                   </a:tcPr>
                 </a:tc>
+                <a:extLst>
+                  <a:ext uri="{0D108BD9-81ED-4DB2-BD59-A6C34878D82A}">
+                    <a16:rowId xmlns:a16="http://schemas.microsoft.com/office/drawing/2014/main" val="10005"/>
+                  </a:ext>
+                </a:extLst>
               </a:tr>
             </a:tbl>
           </a:graphicData>
@@ -8219,7 +8167,7 @@
           </a:prstGeom>
           <a:extLst>
             <a:ext uri="{C572A759-6A51-4108-AA02-DFA0A04FC94B}">
-              <ma14:wrappingTextBoxFlag xmlns:ma14="http://schemas.microsoft.com/office/mac/drawingml/2011/main" val="0"/>
+              <ma14:wrappingTextBoxFlag xmlns:ma14="http://schemas.microsoft.com/office/mac/drawingml/2011/main" xmlns="" val="0"/>
             </a:ext>
           </a:extLst>
         </p:spPr>
@@ -8237,7 +8185,7 @@
           <a:p>
             <a:pPr algn="r"/>
             <a:fld id="{F7021451-1387-4CA6-816F-3879F97B5CBC}" type="slidenum">
-              <a:rPr b="0" lang="en-US"/>
+              <a:rPr lang="en-US" b="0"/>
               <a:t>5</a:t>
             </a:fld>
             <a:endParaRPr lang="en-US"/>
@@ -8272,9 +8220,11 @@
       <p:sp>
         <p:nvSpPr>
           <p:cNvPr id="2" name="Text 0"/>
-          <p:cNvSpPr/>
+          <p:cNvSpPr>
+            <a:spLocks noGrp="1"/>
+          </p:cNvSpPr>
           <p:nvPr>
-            <p:ph idx="100" type="title" hasCustomPrompt="1"/>
+            <p:ph type="title" idx="100" hasCustomPrompt="1"/>
           </p:nvPr>
         </p:nvSpPr>
         <p:spPr>
@@ -8292,7 +8242,7 @@
           <a:bodyPr wrap="square" lIns="0" tIns="0" rIns="0" bIns="0" rtlCol="0" anchor="t"/>
           <a:lstStyle/>
           <a:p>
-            <a:pPr algn="l" indent="0" marL="0">
+            <a:pPr marL="0" indent="0" algn="l">
               <a:buNone/>
             </a:pPr>
             <a:r>
@@ -8333,6 +8283,10 @@
             <a:prstDash val="solid"/>
           </a:ln>
         </p:spPr>
+        <p:txBody>
+          <a:bodyPr/>
+          <a:p/>
+        </p:txBody>
       </p:sp>
       <p:sp>
         <p:nvSpPr>
@@ -8358,6 +8312,10 @@
             <a:prstDash val="solid"/>
           </a:ln>
         </p:spPr>
+        <p:txBody>
+          <a:bodyPr/>
+          <a:p/>
+        </p:txBody>
       </p:sp>
       <p:sp>
         <p:nvSpPr>
@@ -8380,7 +8338,7 @@
           <a:bodyPr wrap="square" lIns="0" tIns="0" rIns="0" bIns="0" rtlCol="0" anchor="ctr"/>
           <a:lstStyle/>
           <a:p>
-            <a:pPr algn="ctr" indent="0" marL="0">
+            <a:pPr marL="0" indent="0" algn="ctr">
               <a:buNone/>
             </a:pPr>
             <a:r>
@@ -8416,7 +8374,7 @@
           <a:bodyPr wrap="square" lIns="0" tIns="0" rIns="0" bIns="0" rtlCol="0" anchor="t"/>
           <a:lstStyle/>
           <a:p>
-            <a:pPr indent="0" marL="0">
+            <a:pPr marL="0" indent="0">
               <a:buNone/>
             </a:pPr>
             <a:r>
@@ -8452,7 +8410,7 @@
           <a:bodyPr wrap="square" lIns="0" tIns="0" rIns="0" bIns="0" rtlCol="0" anchor="t"/>
           <a:lstStyle/>
           <a:p>
-            <a:pPr indent="0" marL="0">
+            <a:pPr marL="0" indent="0">
               <a:buNone/>
             </a:pPr>
             <a:r>
@@ -8493,6 +8451,10 @@
             <a:prstDash val="solid"/>
           </a:ln>
         </p:spPr>
+        <p:txBody>
+          <a:bodyPr/>
+          <a:p/>
+        </p:txBody>
       </p:sp>
       <p:sp>
         <p:nvSpPr>
@@ -8518,6 +8480,10 @@
             <a:prstDash val="solid"/>
           </a:ln>
         </p:spPr>
+        <p:txBody>
+          <a:bodyPr/>
+          <a:p/>
+        </p:txBody>
       </p:sp>
       <p:sp>
         <p:nvSpPr>
@@ -8540,7 +8506,7 @@
           <a:bodyPr wrap="square" lIns="0" tIns="0" rIns="0" bIns="0" rtlCol="0" anchor="ctr"/>
           <a:lstStyle/>
           <a:p>
-            <a:pPr algn="ctr" indent="0" marL="0">
+            <a:pPr marL="0" indent="0" algn="ctr">
               <a:buNone/>
             </a:pPr>
             <a:r>
@@ -8576,7 +8542,7 @@
           <a:bodyPr wrap="square" lIns="0" tIns="0" rIns="0" bIns="0" rtlCol="0" anchor="t"/>
           <a:lstStyle/>
           <a:p>
-            <a:pPr indent="0" marL="0">
+            <a:pPr marL="0" indent="0">
               <a:buNone/>
             </a:pPr>
             <a:r>
@@ -8612,7 +8578,7 @@
           <a:bodyPr wrap="square" lIns="0" tIns="0" rIns="0" bIns="0" rtlCol="0" anchor="t"/>
           <a:lstStyle/>
           <a:p>
-            <a:pPr indent="0" marL="0">
+            <a:pPr marL="0" indent="0">
               <a:buNone/>
             </a:pPr>
             <a:r>
@@ -8653,6 +8619,10 @@
             <a:prstDash val="solid"/>
           </a:ln>
         </p:spPr>
+        <p:txBody>
+          <a:bodyPr/>
+          <a:p/>
+        </p:txBody>
       </p:sp>
       <p:sp>
         <p:nvSpPr>
@@ -8678,6 +8648,10 @@
             <a:prstDash val="solid"/>
           </a:ln>
         </p:spPr>
+        <p:txBody>
+          <a:bodyPr/>
+          <a:p/>
+        </p:txBody>
       </p:sp>
       <p:sp>
         <p:nvSpPr>
@@ -8700,7 +8674,7 @@
           <a:bodyPr wrap="square" lIns="0" tIns="0" rIns="0" bIns="0" rtlCol="0" anchor="ctr"/>
           <a:lstStyle/>
           <a:p>
-            <a:pPr algn="ctr" indent="0" marL="0">
+            <a:pPr marL="0" indent="0" algn="ctr">
               <a:buNone/>
             </a:pPr>
             <a:r>
@@ -8736,7 +8710,7 @@
           <a:bodyPr wrap="square" lIns="0" tIns="0" rIns="0" bIns="0" rtlCol="0" anchor="t"/>
           <a:lstStyle/>
           <a:p>
-            <a:pPr indent="0" marL="0">
+            <a:pPr marL="0" indent="0">
               <a:buNone/>
             </a:pPr>
             <a:r>
@@ -8772,7 +8746,7 @@
           <a:bodyPr wrap="square" lIns="0" tIns="0" rIns="0" bIns="0" rtlCol="0" anchor="t"/>
           <a:lstStyle/>
           <a:p>
-            <a:pPr indent="0" marL="0">
+            <a:pPr marL="0" indent="0">
               <a:buNone/>
             </a:pPr>
             <a:r>
@@ -8781,7 +8755,7 @@
                   <a:schemeClr val="bg2"/>
                 </a:solidFill>
               </a:rPr>
-              <a:t>В один клик из Phantom, из любой страны</a:t>
+              <a:t>Первый раз с подсказками, затем один клик</a:t>
             </a:r>
             <a:endParaRPr lang="en-US" sz="1400" dirty="0"/>
           </a:p>
@@ -8813,6 +8787,10 @@
             <a:prstDash val="solid"/>
           </a:ln>
         </p:spPr>
+        <p:txBody>
+          <a:bodyPr/>
+          <a:p/>
+        </p:txBody>
       </p:sp>
       <p:sp>
         <p:nvSpPr>
@@ -8838,6 +8816,10 @@
             <a:prstDash val="solid"/>
           </a:ln>
         </p:spPr>
+        <p:txBody>
+          <a:bodyPr/>
+          <a:p/>
+        </p:txBody>
       </p:sp>
       <p:sp>
         <p:nvSpPr>
@@ -8860,7 +8842,7 @@
           <a:bodyPr wrap="square" lIns="0" tIns="0" rIns="0" bIns="0" rtlCol="0" anchor="ctr"/>
           <a:lstStyle/>
           <a:p>
-            <a:pPr algn="ctr" indent="0" marL="0">
+            <a:pPr marL="0" indent="0" algn="ctr">
               <a:buNone/>
             </a:pPr>
             <a:r>
@@ -8896,7 +8878,7 @@
           <a:bodyPr wrap="square" lIns="0" tIns="0" rIns="0" bIns="0" rtlCol="0" anchor="t"/>
           <a:lstStyle/>
           <a:p>
-            <a:pPr indent="0" marL="0">
+            <a:pPr marL="0" indent="0">
               <a:buNone/>
             </a:pPr>
             <a:r>
@@ -8932,7 +8914,7 @@
           <a:bodyPr wrap="square" lIns="0" tIns="0" rIns="0" bIns="0" rtlCol="0" anchor="t"/>
           <a:lstStyle/>
           <a:p>
-            <a:pPr indent="0" marL="0">
+            <a:pPr marL="0" indent="0">
               <a:buNone/>
             </a:pPr>
             <a:r>
@@ -8973,6 +8955,10 @@
             <a:prstDash val="solid"/>
           </a:ln>
         </p:spPr>
+        <p:txBody>
+          <a:bodyPr/>
+          <a:p/>
+        </p:txBody>
       </p:sp>
       <p:sp>
         <p:nvSpPr>
@@ -8998,6 +8984,10 @@
             <a:prstDash val="solid"/>
           </a:ln>
         </p:spPr>
+        <p:txBody>
+          <a:bodyPr/>
+          <a:p/>
+        </p:txBody>
       </p:sp>
       <p:sp>
         <p:nvSpPr>
@@ -9020,7 +9010,7 @@
           <a:bodyPr wrap="square" lIns="0" tIns="0" rIns="0" bIns="0" rtlCol="0" anchor="ctr"/>
           <a:lstStyle/>
           <a:p>
-            <a:pPr algn="ctr" indent="0" marL="0">
+            <a:pPr marL="0" indent="0" algn="ctr">
               <a:buNone/>
             </a:pPr>
             <a:r>
@@ -9056,7 +9046,7 @@
           <a:bodyPr wrap="square" lIns="0" tIns="0" rIns="0" bIns="0" rtlCol="0" anchor="t"/>
           <a:lstStyle/>
           <a:p>
-            <a:pPr indent="0" marL="0">
+            <a:pPr marL="0" indent="0">
               <a:buNone/>
             </a:pPr>
             <a:r>
@@ -9092,7 +9082,7 @@
           <a:bodyPr wrap="square" lIns="0" tIns="0" rIns="0" bIns="0" rtlCol="0" anchor="t"/>
           <a:lstStyle/>
           <a:p>
-            <a:pPr indent="0" marL="0">
+            <a:pPr marL="0" indent="0">
               <a:buNone/>
             </a:pPr>
             <a:r>
@@ -9133,6 +9123,10 @@
             <a:prstDash val="solid"/>
           </a:ln>
         </p:spPr>
+        <p:txBody>
+          <a:bodyPr/>
+          <a:p/>
+        </p:txBody>
       </p:sp>
       <p:sp>
         <p:nvSpPr>
@@ -9155,7 +9149,7 @@
           <a:bodyPr wrap="square" lIns="0" tIns="0" rIns="0" bIns="0" rtlCol="0" anchor="ctr"/>
           <a:lstStyle/>
           <a:p>
-            <a:pPr algn="ctr" indent="0" marL="0">
+            <a:pPr marL="0" indent="0" algn="ctr">
               <a:buNone/>
             </a:pPr>
             <a:r>
@@ -9172,7 +9166,7 @@
       </p:sp>
       <p:sp>
         <p:nvSpPr>
-          <p:cNvPr id="25" name="Slide Number Placeholder 0"/>
+          <p:cNvPr id="3" name="Slide Number Placeholder 0"/>
           <p:cNvSpPr>
             <a:spLocks noGrp="1"/>
           </p:cNvSpPr>
@@ -9190,7 +9184,7 @@
           </a:prstGeom>
           <a:extLst>
             <a:ext uri="{C572A759-6A51-4108-AA02-DFA0A04FC94B}">
-              <ma14:wrappingTextBoxFlag xmlns:ma14="http://schemas.microsoft.com/office/mac/drawingml/2011/main" val="0"/>
+              <ma14:wrappingTextBoxFlag xmlns:ma14="http://schemas.microsoft.com/office/mac/drawingml/2011/main" xmlns="" val="0"/>
             </a:ext>
           </a:extLst>
         </p:spPr>
@@ -9208,7 +9202,7 @@
           <a:p>
             <a:pPr algn="r"/>
             <a:fld id="{F7021451-1387-4CA6-816F-3879F97B5CBC}" type="slidenum">
-              <a:rPr b="0" lang="en-US"/>
+              <a:rPr lang="en-US" b="0"/>
               <a:t>6</a:t>
             </a:fld>
             <a:endParaRPr lang="en-US"/>
@@ -9243,9 +9237,11 @@
       <p:sp>
         <p:nvSpPr>
           <p:cNvPr id="2" name="Text 0"/>
-          <p:cNvSpPr/>
+          <p:cNvSpPr>
+            <a:spLocks noGrp="1"/>
+          </p:cNvSpPr>
           <p:nvPr>
-            <p:ph idx="100" type="title" hasCustomPrompt="1"/>
+            <p:ph type="title" idx="100" hasCustomPrompt="1"/>
           </p:nvPr>
         </p:nvSpPr>
         <p:spPr>
@@ -9263,7 +9259,7 @@
           <a:bodyPr wrap="square" lIns="0" tIns="0" rIns="0" bIns="0" rtlCol="0" anchor="t"/>
           <a:lstStyle/>
           <a:p>
-            <a:pPr algn="l" indent="0" marL="0">
+            <a:pPr marL="0" indent="0" algn="l">
               <a:buNone/>
             </a:pPr>
             <a:r>
@@ -9304,17 +9300,21 @@
             <a:prstDash val="solid"/>
           </a:ln>
         </p:spPr>
+        <p:txBody>
+          <a:bodyPr/>
+          <a:p/>
+        </p:txBody>
       </p:sp>
       <p:pic>
         <p:nvPicPr>
-          <p:cNvPr id="5" name="Image 0" descr="Страница оплаты счёта: сумма, сплит, кнопка акта">    </p:cNvPr>
+          <p:cNvPr id="5" name="Image 0" descr="Страница оплаты счёта: сумма, сплит, кнопка акта"/>
           <p:cNvPicPr>
             <a:picLocks noChangeAspect="1"/>
           </p:cNvPicPr>
           <p:nvPr/>
         </p:nvPicPr>
         <p:blipFill>
-          <a:blip r:embed="rId1"/>
+          <a:blip r:embed="rId3"/>
           <a:stretch>
             <a:fillRect/>
           </a:stretch>
@@ -9355,17 +9355,21 @@
             <a:prstDash val="solid"/>
           </a:ln>
         </p:spPr>
+        <p:txBody>
+          <a:bodyPr/>
+          <a:p/>
+        </p:txBody>
       </p:sp>
       <p:pic>
         <p:nvPicPr>
-          <p:cNvPr id="7" name="Image 1" descr="Акт выполненных работ с таблицей и итогом">    </p:cNvPr>
+          <p:cNvPr id="7" name="Image 1" descr="Акт выполненных работ с таблицей и итогом"/>
           <p:cNvPicPr>
             <a:picLocks noChangeAspect="1"/>
           </p:cNvPicPr>
           <p:nvPr/>
         </p:nvPicPr>
         <p:blipFill>
-          <a:blip r:embed="rId2"/>
+          <a:blip r:embed="rId4"/>
           <a:stretch>
             <a:fillRect/>
           </a:stretch>
@@ -9401,7 +9405,7 @@
           <a:bodyPr wrap="square" lIns="0" tIns="0" rIns="0" bIns="0" rtlCol="0" anchor="t"/>
           <a:lstStyle/>
           <a:p>
-            <a:pPr indent="0" marL="0">
+            <a:pPr marL="0" indent="0">
               <a:buNone/>
             </a:pPr>
             <a:r>
@@ -9437,7 +9441,7 @@
           <a:bodyPr wrap="square" lIns="0" tIns="0" rIns="0" bIns="0" rtlCol="0" anchor="t"/>
           <a:lstStyle/>
           <a:p>
-            <a:pPr indent="0" marL="0">
+            <a:pPr marL="0" indent="0">
               <a:buNone/>
             </a:pPr>
             <a:r>
@@ -9476,17 +9480,21 @@
             <a:prstDash val="solid"/>
           </a:ln>
         </p:spPr>
+        <p:txBody>
+          <a:bodyPr/>
+          <a:p/>
+        </p:txBody>
       </p:sp>
       <p:pic>
         <p:nvPicPr>
-          <p:cNvPr id="11" name="Image 2" descr="check">    </p:cNvPr>
+          <p:cNvPr id="11" name="Image 2" descr="check"/>
           <p:cNvPicPr>
             <a:picLocks noChangeAspect="1"/>
           </p:cNvPicPr>
           <p:nvPr/>
         </p:nvPicPr>
         <p:blipFill>
-          <a:blip r:embed="rId3"/>
+          <a:blip r:embed="rId5"/>
           <a:stretch>
             <a:fillRect/>
           </a:stretch>
@@ -9522,7 +9530,7 @@
           <a:bodyPr wrap="square" lIns="0" tIns="0" rIns="0" bIns="0" rtlCol="0" anchor="t"/>
           <a:lstStyle/>
           <a:p>
-            <a:pPr indent="0" marL="0">
+            <a:pPr marL="0" indent="0">
               <a:buNone/>
             </a:pPr>
             <a:r>
@@ -9561,17 +9569,21 @@
             <a:prstDash val="solid"/>
           </a:ln>
         </p:spPr>
+        <p:txBody>
+          <a:bodyPr/>
+          <a:p/>
+        </p:txBody>
       </p:sp>
       <p:pic>
         <p:nvPicPr>
-          <p:cNvPr id="14" name="Image 3" descr="bolt">    </p:cNvPr>
+          <p:cNvPr id="14" name="Image 3" descr="bolt"/>
           <p:cNvPicPr>
             <a:picLocks noChangeAspect="1"/>
           </p:cNvPicPr>
           <p:nvPr/>
         </p:nvPicPr>
         <p:blipFill>
-          <a:blip r:embed="rId4"/>
+          <a:blip r:embed="rId6"/>
           <a:stretch>
             <a:fillRect/>
           </a:stretch>
@@ -9607,7 +9619,7 @@
           <a:bodyPr wrap="square" lIns="0" tIns="0" rIns="0" bIns="0" rtlCol="0" anchor="t"/>
           <a:lstStyle/>
           <a:p>
-            <a:pPr indent="0" marL="0">
+            <a:pPr marL="0" indent="0">
               <a:buNone/>
             </a:pPr>
             <a:r>
@@ -9616,7 +9628,7 @@
                   <a:schemeClr val="bg1"/>
                 </a:solidFill>
               </a:rPr>
-              <a:t>Оплата в один клик, сплит в одной транзакции</a:t>
+              <a:t>Оплата кошельком, сплит в одной транзакции</a:t>
             </a:r>
             <a:endParaRPr lang="en-US" sz="1400" dirty="0"/>
           </a:p>
@@ -9646,17 +9658,21 @@
             <a:prstDash val="solid"/>
           </a:ln>
         </p:spPr>
+        <p:txBody>
+          <a:bodyPr/>
+          <a:p/>
+        </p:txBody>
       </p:sp>
       <p:pic>
         <p:nvPicPr>
-          <p:cNvPr id="17" name="Image 4" descr="file">    </p:cNvPr>
+          <p:cNvPr id="17" name="Image 4" descr="file"/>
           <p:cNvPicPr>
             <a:picLocks noChangeAspect="1"/>
           </p:cNvPicPr>
           <p:nvPr/>
         </p:nvPicPr>
         <p:blipFill>
-          <a:blip r:embed="rId5"/>
+          <a:blip r:embed="rId7"/>
           <a:stretch>
             <a:fillRect/>
           </a:stretch>
@@ -9692,7 +9708,7 @@
           <a:bodyPr wrap="square" lIns="0" tIns="0" rIns="0" bIns="0" rtlCol="0" anchor="t"/>
           <a:lstStyle/>
           <a:p>
-            <a:pPr indent="0" marL="0">
+            <a:pPr marL="0" indent="0">
               <a:buNone/>
             </a:pPr>
             <a:r>
@@ -9701,7 +9717,7 @@
                   <a:schemeClr val="bg1"/>
                 </a:solidFill>
               </a:rPr>
-              <a:t>Акт по форме Р-1 готов к печати</a:t>
+              <a:t>Акт на основе Р-1 готов к печати</a:t>
             </a:r>
             <a:endParaRPr lang="en-US" sz="1400" dirty="0"/>
           </a:p>
@@ -9728,7 +9744,7 @@
           <a:bodyPr wrap="square" lIns="0" tIns="0" rIns="0" bIns="0" rtlCol="0" anchor="t"/>
           <a:lstStyle/>
           <a:p>
-            <a:pPr indent="0" marL="0">
+            <a:pPr marL="0" indent="0">
               <a:buNone/>
             </a:pPr>
             <a:r>
@@ -9763,7 +9779,7 @@
           </a:prstGeom>
           <a:extLst>
             <a:ext uri="{C572A759-6A51-4108-AA02-DFA0A04FC94B}">
-              <ma14:wrappingTextBoxFlag xmlns:ma14="http://schemas.microsoft.com/office/mac/drawingml/2011/main" val="0"/>
+              <ma14:wrappingTextBoxFlag xmlns:ma14="http://schemas.microsoft.com/office/mac/drawingml/2011/main" xmlns="" val="0"/>
             </a:ext>
           </a:extLst>
         </p:spPr>
@@ -9781,7 +9797,7 @@
           <a:p>
             <a:pPr algn="r"/>
             <a:fld id="{F7021451-1387-4CA6-816F-3879F97B5CBC}" type="slidenum">
-              <a:rPr b="0" lang="en-US"/>
+              <a:rPr lang="en-US" b="0"/>
               <a:t>7</a:t>
             </a:fld>
             <a:endParaRPr lang="en-US"/>
@@ -9816,9 +9832,11 @@
       <p:sp>
         <p:nvSpPr>
           <p:cNvPr id="2" name="Text 0"/>
-          <p:cNvSpPr/>
+          <p:cNvSpPr>
+            <a:spLocks noGrp="1"/>
+          </p:cNvSpPr>
           <p:nvPr>
-            <p:ph idx="100" type="title" hasCustomPrompt="1"/>
+            <p:ph type="title" idx="100" hasCustomPrompt="1"/>
           </p:nvPr>
         </p:nvSpPr>
         <p:spPr>
@@ -9836,7 +9854,7 @@
           <a:bodyPr wrap="square" lIns="0" tIns="0" rIns="0" bIns="0" rtlCol="0" anchor="t"/>
           <a:lstStyle/>
           <a:p>
-            <a:pPr algn="l" indent="0" marL="0">
+            <a:pPr marL="0" indent="0" algn="l">
               <a:buNone/>
             </a:pPr>
             <a:r>
@@ -9926,7 +9944,7 @@
           <a:bodyPr wrap="square" lIns="0" tIns="0" rIns="0" bIns="0" rtlCol="0" anchor="t"/>
           <a:lstStyle/>
           <a:p>
-            <a:pPr indent="0" marL="0">
+            <a:pPr marL="0" indent="0">
               <a:buNone/>
             </a:pPr>
             <a:r>
@@ -9940,7 +9958,7 @@
             <a:endParaRPr lang="en-US" sz="1400" dirty="0"/>
           </a:p>
           <a:p>
-            <a:pPr indent="0" marL="0">
+            <a:pPr marL="0" indent="0">
               <a:buNone/>
             </a:pPr>
             <a:r>
@@ -9954,7 +9972,7 @@
             <a:endParaRPr lang="en-US" sz="1400" dirty="0"/>
           </a:p>
           <a:p>
-            <a:pPr indent="0" marL="0">
+            <a:pPr marL="0" indent="0">
               <a:buNone/>
             </a:pPr>
             <a:r>
@@ -10017,7 +10035,7 @@
           <a:bodyPr wrap="square" lIns="0" tIns="0" rIns="0" bIns="0" rtlCol="0" anchor="ctr"/>
           <a:lstStyle/>
           <a:p>
-            <a:pPr algn="ctr" indent="0" marL="0">
+            <a:pPr marL="0" indent="0" algn="ctr">
               <a:buNone/>
             </a:pPr>
             <a:r>
@@ -10080,7 +10098,7 @@
           <a:bodyPr wrap="square" lIns="0" tIns="0" rIns="0" bIns="0" rtlCol="0" anchor="t"/>
           <a:lstStyle/>
           <a:p>
-            <a:pPr indent="0" marL="0">
+            <a:pPr marL="0" indent="0">
               <a:buNone/>
             </a:pPr>
             <a:r>
@@ -10094,7 +10112,7 @@
             <a:endParaRPr lang="en-US" sz="1400" dirty="0"/>
           </a:p>
           <a:p>
-            <a:pPr indent="0" marL="0">
+            <a:pPr marL="0" indent="0">
               <a:buNone/>
             </a:pPr>
             <a:r>
@@ -10108,7 +10126,7 @@
             <a:endParaRPr lang="en-US" sz="1400" dirty="0"/>
           </a:p>
           <a:p>
-            <a:pPr indent="0" marL="0">
+            <a:pPr marL="0" indent="0">
               <a:buNone/>
             </a:pPr>
             <a:r>
@@ -10171,7 +10189,7 @@
           <a:bodyPr wrap="square" lIns="0" tIns="0" rIns="0" bIns="0" rtlCol="0" anchor="ctr"/>
           <a:lstStyle/>
           <a:p>
-            <a:pPr algn="ctr" indent="0" marL="0">
+            <a:pPr marL="0" indent="0" algn="ctr">
               <a:buNone/>
             </a:pPr>
             <a:r>
@@ -10207,7 +10225,7 @@
           <a:bodyPr wrap="square" lIns="0" tIns="0" rIns="0" bIns="0" rtlCol="0" anchor="t"/>
           <a:lstStyle/>
           <a:p>
-            <a:pPr indent="0" marL="0">
+            <a:pPr marL="0" indent="0">
               <a:buNone/>
             </a:pPr>
             <a:r>
@@ -10251,14 +10269,14 @@
       </p:sp>
       <p:pic>
         <p:nvPicPr>
-          <p:cNvPr id="15" name="Image 0" descr="Страница Финансы и налоги: доход, налог, график по месяцам">    </p:cNvPr>
+          <p:cNvPr id="15" name="Image 0" descr="Страница Финансы и налоги: доход, налог, график по месяцам"/>
           <p:cNvPicPr>
             <a:picLocks noChangeAspect="1"/>
           </p:cNvPicPr>
           <p:nvPr/>
         </p:nvPicPr>
         <p:blipFill>
-          <a:blip r:embed="rId1"/>
+          <a:blip r:embed="rId3"/>
           <a:stretch>
             <a:fillRect/>
           </a:stretch>
@@ -10294,7 +10312,7 @@
           <a:bodyPr wrap="square" lIns="0" tIns="0" rIns="0" bIns="0" rtlCol="0" anchor="t"/>
           <a:lstStyle/>
           <a:p>
-            <a:pPr indent="0" marL="0">
+            <a:pPr marL="0" indent="0">
               <a:buNone/>
             </a:pPr>
             <a:r>
@@ -10329,7 +10347,7 @@
           </a:prstGeom>
           <a:extLst>
             <a:ext uri="{C572A759-6A51-4108-AA02-DFA0A04FC94B}">
-              <ma14:wrappingTextBoxFlag xmlns:ma14="http://schemas.microsoft.com/office/mac/drawingml/2011/main" val="0"/>
+              <ma14:wrappingTextBoxFlag xmlns:ma14="http://schemas.microsoft.com/office/mac/drawingml/2011/main" xmlns="" val="0"/>
             </a:ext>
           </a:extLst>
         </p:spPr>
@@ -10347,7 +10365,7 @@
           <a:p>
             <a:pPr algn="r"/>
             <a:fld id="{F7021451-1387-4CA6-816F-3879F97B5CBC}" type="slidenum">
-              <a:rPr b="0" lang="en-US"/>
+              <a:rPr lang="en-US" b="0"/>
               <a:t>8</a:t>
             </a:fld>
             <a:endParaRPr lang="en-US"/>
@@ -10382,9 +10400,11 @@
       <p:sp>
         <p:nvSpPr>
           <p:cNvPr id="2" name="Text 0"/>
-          <p:cNvSpPr/>
+          <p:cNvSpPr>
+            <a:spLocks noGrp="1"/>
+          </p:cNvSpPr>
           <p:nvPr>
-            <p:ph idx="100" type="title" hasCustomPrompt="1"/>
+            <p:ph type="title" idx="100" hasCustomPrompt="1"/>
           </p:nvPr>
         </p:nvSpPr>
         <p:spPr>
@@ -10402,7 +10422,7 @@
           <a:bodyPr wrap="square" lIns="0" tIns="0" rIns="0" bIns="0" rtlCol="0" anchor="t"/>
           <a:lstStyle/>
           <a:p>
-            <a:pPr algn="l" indent="0" marL="0">
+            <a:pPr marL="0" indent="0" algn="l">
               <a:buNone/>
             </a:pPr>
             <a:r>
@@ -10443,6 +10463,10 @@
             <a:prstDash val="solid"/>
           </a:ln>
         </p:spPr>
+        <p:txBody>
+          <a:bodyPr/>
+          <a:p/>
+        </p:txBody>
       </p:sp>
       <p:sp>
         <p:nvSpPr>
@@ -10468,6 +10492,10 @@
             <a:prstDash val="solid"/>
           </a:ln>
         </p:spPr>
+        <p:txBody>
+          <a:bodyPr/>
+          <a:p/>
+        </p:txBody>
       </p:sp>
       <p:sp>
         <p:nvSpPr>
@@ -10490,7 +10518,7 @@
           <a:bodyPr wrap="square" lIns="0" tIns="0" rIns="0" bIns="0" rtlCol="0" anchor="ctr"/>
           <a:lstStyle/>
           <a:p>
-            <a:pPr algn="ctr" indent="0" marL="0">
+            <a:pPr marL="0" indent="0" algn="ctr">
               <a:buNone/>
             </a:pPr>
             <a:r>
@@ -10526,7 +10554,7 @@
           <a:bodyPr wrap="square" lIns="0" tIns="0" rIns="0" bIns="0" rtlCol="0" anchor="t"/>
           <a:lstStyle/>
           <a:p>
-            <a:pPr indent="0" marL="0">
+            <a:pPr marL="0" indent="0">
               <a:buNone/>
             </a:pPr>
             <a:r>
@@ -10562,7 +10590,7 @@
           <a:bodyPr wrap="square" lIns="0" tIns="0" rIns="0" bIns="0" rtlCol="0" anchor="t"/>
           <a:lstStyle/>
           <a:p>
-            <a:pPr indent="0" marL="0">
+            <a:pPr marL="0" indent="0">
               <a:buNone/>
             </a:pPr>
             <a:r>
@@ -10603,6 +10631,10 @@
             <a:prstDash val="solid"/>
           </a:ln>
         </p:spPr>
+        <p:txBody>
+          <a:bodyPr/>
+          <a:p/>
+        </p:txBody>
       </p:sp>
       <p:sp>
         <p:nvSpPr>
@@ -10628,6 +10660,10 @@
             <a:prstDash val="solid"/>
           </a:ln>
         </p:spPr>
+        <p:txBody>
+          <a:bodyPr/>
+          <a:p/>
+        </p:txBody>
       </p:sp>
       <p:sp>
         <p:nvSpPr>
@@ -10650,7 +10686,7 @@
           <a:bodyPr wrap="square" lIns="0" tIns="0" rIns="0" bIns="0" rtlCol="0" anchor="ctr"/>
           <a:lstStyle/>
           <a:p>
-            <a:pPr algn="ctr" indent="0" marL="0">
+            <a:pPr marL="0" indent="0" algn="ctr">
               <a:buNone/>
             </a:pPr>
             <a:r>
@@ -10686,7 +10722,7 @@
           <a:bodyPr wrap="square" lIns="0" tIns="0" rIns="0" bIns="0" rtlCol="0" anchor="t"/>
           <a:lstStyle/>
           <a:p>
-            <a:pPr indent="0" marL="0">
+            <a:pPr marL="0" indent="0">
               <a:buNone/>
             </a:pPr>
             <a:r>
@@ -10722,7 +10758,7 @@
           <a:bodyPr wrap="square" lIns="0" tIns="0" rIns="0" bIns="0" rtlCol="0" anchor="t"/>
           <a:lstStyle/>
           <a:p>
-            <a:pPr indent="0" marL="0">
+            <a:pPr marL="0" indent="0">
               <a:buNone/>
             </a:pPr>
             <a:r>
@@ -10763,6 +10799,10 @@
             <a:prstDash val="solid"/>
           </a:ln>
         </p:spPr>
+        <p:txBody>
+          <a:bodyPr/>
+          <a:p/>
+        </p:txBody>
       </p:sp>
       <p:sp>
         <p:nvSpPr>
@@ -10788,6 +10828,10 @@
             <a:prstDash val="solid"/>
           </a:ln>
         </p:spPr>
+        <p:txBody>
+          <a:bodyPr/>
+          <a:p/>
+        </p:txBody>
       </p:sp>
       <p:sp>
         <p:nvSpPr>
@@ -10810,7 +10854,7 @@
           <a:bodyPr wrap="square" lIns="0" tIns="0" rIns="0" bIns="0" rtlCol="0" anchor="ctr"/>
           <a:lstStyle/>
           <a:p>
-            <a:pPr algn="ctr" indent="0" marL="0">
+            <a:pPr marL="0" indent="0" algn="ctr">
               <a:buNone/>
             </a:pPr>
             <a:r>
@@ -10846,7 +10890,7 @@
           <a:bodyPr wrap="square" lIns="0" tIns="0" rIns="0" bIns="0" rtlCol="0" anchor="t"/>
           <a:lstStyle/>
           <a:p>
-            <a:pPr indent="0" marL="0">
+            <a:pPr marL="0" indent="0">
               <a:buNone/>
             </a:pPr>
             <a:r>
@@ -10882,7 +10926,7 @@
           <a:bodyPr wrap="square" lIns="0" tIns="0" rIns="0" bIns="0" rtlCol="0" anchor="t"/>
           <a:lstStyle/>
           <a:p>
-            <a:pPr indent="0" marL="0">
+            <a:pPr marL="0" indent="0">
               <a:buNone/>
             </a:pPr>
             <a:r>
@@ -10923,6 +10967,10 @@
             <a:prstDash val="solid"/>
           </a:ln>
         </p:spPr>
+        <p:txBody>
+          <a:bodyPr/>
+          <a:p/>
+        </p:txBody>
       </p:sp>
       <p:sp>
         <p:nvSpPr>
@@ -10948,6 +10996,10 @@
             <a:prstDash val="solid"/>
           </a:ln>
         </p:spPr>
+        <p:txBody>
+          <a:bodyPr/>
+          <a:p/>
+        </p:txBody>
       </p:sp>
       <p:sp>
         <p:nvSpPr>
@@ -10970,7 +11022,7 @@
           <a:bodyPr wrap="square" lIns="0" tIns="0" rIns="0" bIns="0" rtlCol="0" anchor="ctr"/>
           <a:lstStyle/>
           <a:p>
-            <a:pPr algn="ctr" indent="0" marL="0">
+            <a:pPr marL="0" indent="0" algn="ctr">
               <a:buNone/>
             </a:pPr>
             <a:r>
@@ -11006,7 +11058,7 @@
           <a:bodyPr wrap="square" lIns="0" tIns="0" rIns="0" bIns="0" rtlCol="0" anchor="t"/>
           <a:lstStyle/>
           <a:p>
-            <a:pPr indent="0" marL="0">
+            <a:pPr marL="0" indent="0">
               <a:buNone/>
             </a:pPr>
             <a:r>
@@ -11042,7 +11094,7 @@
           <a:bodyPr wrap="square" lIns="0" tIns="0" rIns="0" bIns="0" rtlCol="0" anchor="t"/>
           <a:lstStyle/>
           <a:p>
-            <a:pPr indent="0" marL="0">
+            <a:pPr marL="0" indent="0">
               <a:buNone/>
             </a:pPr>
             <a:r>
@@ -11083,6 +11135,10 @@
             <a:prstDash val="solid"/>
           </a:ln>
         </p:spPr>
+        <p:txBody>
+          <a:bodyPr/>
+          <a:p/>
+        </p:txBody>
       </p:sp>
       <p:sp>
         <p:nvSpPr>
@@ -11105,7 +11161,7 @@
           <a:bodyPr wrap="square" lIns="0" tIns="0" rIns="0" bIns="0" rtlCol="0" anchor="t"/>
           <a:lstStyle/>
           <a:p>
-            <a:pPr indent="0" marL="0">
+            <a:pPr marL="0" indent="0">
               <a:buNone/>
             </a:pPr>
             <a:r>
@@ -11114,7 +11170,7 @@
                   <a:schemeClr val="accent2"/>
                 </a:solidFill>
               </a:rPr>
-              <a:t>Оплаты картой нет сознательно</a:t>
+              <a:t>Прямой оплаты картой нет сознательно</a:t>
             </a:r>
             <a:endParaRPr lang="en-US" sz="2200" dirty="0"/>
           </a:p>
@@ -11141,7 +11197,7 @@
           <a:bodyPr wrap="square" lIns="0" tIns="0" rIns="0" bIns="0" rtlCol="0" anchor="t"/>
           <a:lstStyle/>
           <a:p>
-            <a:pPr indent="0" marL="0">
+            <a:pPr marL="0" indent="0">
               <a:buNone/>
             </a:pPr>
             <a:r>
@@ -11150,7 +11206,7 @@
                   <a:schemeClr val="bg1"/>
                 </a:solidFill>
               </a:rPr>
-              <a:t>Платёжные системы берут свой процент и встают между клиентом и исполнителем. Здесь деньги идут напрямую, а процент один: наш 1%</a:t>
+              <a:t>Платёжные системы берут свой процент и встают между клиентом и исполнителем. Здесь деньги идут напрямую, наша комиссия 1%. Покупку SOL и её комиссию показывает Phantom</a:t>
             </a:r>
             <a:endParaRPr lang="en-US" sz="1600" dirty="0"/>
           </a:p>
@@ -11177,7 +11233,7 @@
           <a:bodyPr wrap="square" lIns="0" tIns="0" rIns="0" bIns="0" rtlCol="0" anchor="t"/>
           <a:lstStyle/>
           <a:p>
-            <a:pPr indent="0" marL="0">
+            <a:pPr marL="0" indent="0">
               <a:buNone/>
             </a:pPr>
             <a:r>
@@ -11194,7 +11250,7 @@
       </p:sp>
       <p:sp>
         <p:nvSpPr>
-          <p:cNvPr id="25" name="Slide Number Placeholder 0"/>
+          <p:cNvPr id="3" name="Slide Number Placeholder 0"/>
           <p:cNvSpPr>
             <a:spLocks noGrp="1"/>
           </p:cNvSpPr>
@@ -11212,7 +11268,7 @@
           </a:prstGeom>
           <a:extLst>
             <a:ext uri="{C572A759-6A51-4108-AA02-DFA0A04FC94B}">
-              <ma14:wrappingTextBoxFlag xmlns:ma14="http://schemas.microsoft.com/office/mac/drawingml/2011/main" val="0"/>
+              <ma14:wrappingTextBoxFlag xmlns:ma14="http://schemas.microsoft.com/office/mac/drawingml/2011/main" xmlns="" val="0"/>
             </a:ext>
           </a:extLst>
         </p:spPr>
@@ -11230,7 +11286,7 @@
           <a:p>
             <a:pPr algn="r"/>
             <a:fld id="{F7021451-1387-4CA6-816F-3879F97B5CBC}" type="slidenum">
-              <a:rPr b="0" lang="en-US"/>
+              <a:rPr lang="en-US" b="0"/>
               <a:t>9</a:t>
             </a:fld>
             <a:endParaRPr lang="en-US"/>
@@ -11538,4 +11594,299 @@
     </a:ext>
   </a:extLst>
 </a:theme>
+</file>
+
+<file path=ppt/theme/theme2.xml><?xml version="1.0" encoding="utf-8"?>
+<a:theme xmlns:a="http://schemas.openxmlformats.org/drawingml/2006/main" name="Тема Office">
+  <a:themeElements>
+    <a:clrScheme name="Стандартная">
+      <a:dk1>
+        <a:sysClr val="windowText" lastClr="000000"/>
+      </a:dk1>
+      <a:lt1>
+        <a:sysClr val="window" lastClr="FFFFFF"/>
+      </a:lt1>
+      <a:dk2>
+        <a:srgbClr val="44546A"/>
+      </a:dk2>
+      <a:lt2>
+        <a:srgbClr val="E7E6E6"/>
+      </a:lt2>
+      <a:accent1>
+        <a:srgbClr val="4472C4"/>
+      </a:accent1>
+      <a:accent2>
+        <a:srgbClr val="ED7D31"/>
+      </a:accent2>
+      <a:accent3>
+        <a:srgbClr val="A5A5A5"/>
+      </a:accent3>
+      <a:accent4>
+        <a:srgbClr val="FFC000"/>
+      </a:accent4>
+      <a:accent5>
+        <a:srgbClr val="5B9BD5"/>
+      </a:accent5>
+      <a:accent6>
+        <a:srgbClr val="70AD47"/>
+      </a:accent6>
+      <a:hlink>
+        <a:srgbClr val="0563C1"/>
+      </a:hlink>
+      <a:folHlink>
+        <a:srgbClr val="954F72"/>
+      </a:folHlink>
+    </a:clrScheme>
+    <a:fontScheme name="Стандартная">
+      <a:majorFont>
+        <a:latin typeface="Calibri Light" panose="020F0302020204030204"/>
+        <a:ea typeface=""/>
+        <a:cs typeface=""/>
+        <a:font script="Jpan" typeface="游ゴシック Light"/>
+        <a:font script="Hang" typeface="맑은 고딕"/>
+        <a:font script="Hans" typeface="等线 Light"/>
+        <a:font script="Hant" typeface="新細明體"/>
+        <a:font script="Arab" typeface="Times New Roman"/>
+        <a:font script="Hebr" typeface="Times New Roman"/>
+        <a:font script="Thai" typeface="Angsana New"/>
+        <a:font script="Ethi" typeface="Nyala"/>
+        <a:font script="Beng" typeface="Vrinda"/>
+        <a:font script="Gujr" typeface="Shruti"/>
+        <a:font script="Khmr" typeface="MoolBoran"/>
+        <a:font script="Knda" typeface="Tunga"/>
+        <a:font script="Guru" typeface="Raavi"/>
+        <a:font script="Cans" typeface="Euphemia"/>
+        <a:font script="Cher" typeface="Plantagenet Cherokee"/>
+        <a:font script="Yiii" typeface="Microsoft Yi Baiti"/>
+        <a:font script="Tibt" typeface="Microsoft Himalaya"/>
+        <a:font script="Thaa" typeface="MV Boli"/>
+        <a:font script="Deva" typeface="Mangal"/>
+        <a:font script="Telu" typeface="Gautami"/>
+        <a:font script="Taml" typeface="Latha"/>
+        <a:font script="Syrc" typeface="Estrangelo Edessa"/>
+        <a:font script="Orya" typeface="Kalinga"/>
+        <a:font script="Mlym" typeface="Kartika"/>
+        <a:font script="Laoo" typeface="DokChampa"/>
+        <a:font script="Sinh" typeface="Iskoola Pota"/>
+        <a:font script="Mong" typeface="Mongolian Baiti"/>
+        <a:font script="Viet" typeface="Times New Roman"/>
+        <a:font script="Uigh" typeface="Microsoft Uighur"/>
+        <a:font script="Geor" typeface="Sylfaen"/>
+        <a:font script="Armn" typeface="Arial"/>
+        <a:font script="Bugi" typeface="Leelawadee UI"/>
+        <a:font script="Bopo" typeface="Microsoft JhengHei"/>
+        <a:font script="Java" typeface="Javanese Text"/>
+        <a:font script="Lisu" typeface="Segoe UI"/>
+        <a:font script="Mymr" typeface="Myanmar Text"/>
+        <a:font script="Nkoo" typeface="Ebrima"/>
+        <a:font script="Olck" typeface="Nirmala UI"/>
+        <a:font script="Osma" typeface="Ebrima"/>
+        <a:font script="Phag" typeface="Phagspa"/>
+        <a:font script="Syrn" typeface="Estrangelo Edessa"/>
+        <a:font script="Syrj" typeface="Estrangelo Edessa"/>
+        <a:font script="Syre" typeface="Estrangelo Edessa"/>
+        <a:font script="Sora" typeface="Nirmala UI"/>
+        <a:font script="Tale" typeface="Microsoft Tai Le"/>
+        <a:font script="Talu" typeface="Microsoft New Tai Lue"/>
+        <a:font script="Tfng" typeface="Ebrima"/>
+      </a:majorFont>
+      <a:minorFont>
+        <a:latin typeface="Calibri" panose="020F0502020204030204"/>
+        <a:ea typeface=""/>
+        <a:cs typeface=""/>
+        <a:font script="Jpan" typeface="游ゴシック"/>
+        <a:font script="Hang" typeface="맑은 고딕"/>
+        <a:font script="Hans" typeface="等线"/>
+        <a:font script="Hant" typeface="新細明體"/>
+        <a:font script="Arab" typeface="Arial"/>
+        <a:font script="Hebr" typeface="Arial"/>
+        <a:font script="Thai" typeface="Cordia New"/>
+        <a:font script="Ethi" typeface="Nyala"/>
+        <a:font script="Beng" typeface="Vrinda"/>
+        <a:font script="Gujr" typeface="Shruti"/>
+        <a:font script="Khmr" typeface="DaunPenh"/>
+        <a:font script="Knda" typeface="Tunga"/>
+        <a:font script="Guru" typeface="Raavi"/>
+        <a:font script="Cans" typeface="Euphemia"/>
+        <a:font script="Cher" typeface="Plantagenet Cherokee"/>
+        <a:font script="Yiii" typeface="Microsoft Yi Baiti"/>
+        <a:font script="Tibt" typeface="Microsoft Himalaya"/>
+        <a:font script="Thaa" typeface="MV Boli"/>
+        <a:font script="Deva" typeface="Mangal"/>
+        <a:font script="Telu" typeface="Gautami"/>
+        <a:font script="Taml" typeface="Latha"/>
+        <a:font script="Syrc" typeface="Estrangelo Edessa"/>
+        <a:font script="Orya" typeface="Kalinga"/>
+        <a:font script="Mlym" typeface="Kartika"/>
+        <a:font script="Laoo" typeface="DokChampa"/>
+        <a:font script="Sinh" typeface="Iskoola Pota"/>
+        <a:font script="Mong" typeface="Mongolian Baiti"/>
+        <a:font script="Viet" typeface="Arial"/>
+        <a:font script="Uigh" typeface="Microsoft Uighur"/>
+        <a:font script="Geor" typeface="Sylfaen"/>
+        <a:font script="Armn" typeface="Arial"/>
+        <a:font script="Bugi" typeface="Leelawadee UI"/>
+        <a:font script="Bopo" typeface="Microsoft JhengHei"/>
+        <a:font script="Java" typeface="Javanese Text"/>
+        <a:font script="Lisu" typeface="Segoe UI"/>
+        <a:font script="Mymr" typeface="Myanmar Text"/>
+        <a:font script="Nkoo" typeface="Ebrima"/>
+        <a:font script="Olck" typeface="Nirmala UI"/>
+        <a:font script="Osma" typeface="Ebrima"/>
+        <a:font script="Phag" typeface="Phagspa"/>
+        <a:font script="Syrn" typeface="Estrangelo Edessa"/>
+        <a:font script="Syrj" typeface="Estrangelo Edessa"/>
+        <a:font script="Syre" typeface="Estrangelo Edessa"/>
+        <a:font script="Sora" typeface="Nirmala UI"/>
+        <a:font script="Tale" typeface="Microsoft Tai Le"/>
+        <a:font script="Talu" typeface="Microsoft New Tai Lue"/>
+        <a:font script="Tfng" typeface="Ebrima"/>
+      </a:minorFont>
+    </a:fontScheme>
+    <a:fmtScheme name="Стандартная">
+      <a:fillStyleLst>
+        <a:solidFill>
+          <a:schemeClr val="phClr"/>
+        </a:solidFill>
+        <a:gradFill rotWithShape="1">
+          <a:gsLst>
+            <a:gs pos="0">
+              <a:schemeClr val="phClr">
+                <a:lumMod val="110000"/>
+                <a:satMod val="105000"/>
+                <a:tint val="67000"/>
+              </a:schemeClr>
+            </a:gs>
+            <a:gs pos="50000">
+              <a:schemeClr val="phClr">
+                <a:lumMod val="105000"/>
+                <a:satMod val="103000"/>
+                <a:tint val="73000"/>
+              </a:schemeClr>
+            </a:gs>
+            <a:gs pos="100000">
+              <a:schemeClr val="phClr">
+                <a:lumMod val="105000"/>
+                <a:satMod val="109000"/>
+                <a:tint val="81000"/>
+              </a:schemeClr>
+            </a:gs>
+          </a:gsLst>
+          <a:lin ang="5400000" scaled="0"/>
+        </a:gradFill>
+        <a:gradFill rotWithShape="1">
+          <a:gsLst>
+            <a:gs pos="0">
+              <a:schemeClr val="phClr">
+                <a:satMod val="103000"/>
+                <a:lumMod val="102000"/>
+                <a:tint val="94000"/>
+              </a:schemeClr>
+            </a:gs>
+            <a:gs pos="50000">
+              <a:schemeClr val="phClr">
+                <a:satMod val="110000"/>
+                <a:lumMod val="100000"/>
+                <a:shade val="100000"/>
+              </a:schemeClr>
+            </a:gs>
+            <a:gs pos="100000">
+              <a:schemeClr val="phClr">
+                <a:lumMod val="99000"/>
+                <a:satMod val="120000"/>
+                <a:shade val="78000"/>
+              </a:schemeClr>
+            </a:gs>
+          </a:gsLst>
+          <a:lin ang="5400000" scaled="0"/>
+        </a:gradFill>
+      </a:fillStyleLst>
+      <a:lnStyleLst>
+        <a:ln w="6350" cap="flat" cmpd="sng" algn="ctr">
+          <a:solidFill>
+            <a:schemeClr val="phClr"/>
+          </a:solidFill>
+          <a:prstDash val="solid"/>
+          <a:miter lim="800000"/>
+        </a:ln>
+        <a:ln w="12700" cap="flat" cmpd="sng" algn="ctr">
+          <a:solidFill>
+            <a:schemeClr val="phClr"/>
+          </a:solidFill>
+          <a:prstDash val="solid"/>
+          <a:miter lim="800000"/>
+        </a:ln>
+        <a:ln w="19050" cap="flat" cmpd="sng" algn="ctr">
+          <a:solidFill>
+            <a:schemeClr val="phClr"/>
+          </a:solidFill>
+          <a:prstDash val="solid"/>
+          <a:miter lim="800000"/>
+        </a:ln>
+      </a:lnStyleLst>
+      <a:effectStyleLst>
+        <a:effectStyle>
+          <a:effectLst/>
+        </a:effectStyle>
+        <a:effectStyle>
+          <a:effectLst/>
+        </a:effectStyle>
+        <a:effectStyle>
+          <a:effectLst>
+            <a:outerShdw blurRad="57150" dist="19050" dir="5400000" algn="ctr" rotWithShape="0">
+              <a:srgbClr val="000000">
+                <a:alpha val="63000"/>
+              </a:srgbClr>
+            </a:outerShdw>
+          </a:effectLst>
+        </a:effectStyle>
+      </a:effectStyleLst>
+      <a:bgFillStyleLst>
+        <a:solidFill>
+          <a:schemeClr val="phClr"/>
+        </a:solidFill>
+        <a:solidFill>
+          <a:schemeClr val="phClr">
+            <a:tint val="95000"/>
+            <a:satMod val="170000"/>
+          </a:schemeClr>
+        </a:solidFill>
+        <a:gradFill rotWithShape="1">
+          <a:gsLst>
+            <a:gs pos="0">
+              <a:schemeClr val="phClr">
+                <a:tint val="93000"/>
+                <a:satMod val="150000"/>
+                <a:shade val="98000"/>
+                <a:lumMod val="102000"/>
+              </a:schemeClr>
+            </a:gs>
+            <a:gs pos="50000">
+              <a:schemeClr val="phClr">
+                <a:tint val="98000"/>
+                <a:satMod val="130000"/>
+                <a:shade val="90000"/>
+                <a:lumMod val="103000"/>
+              </a:schemeClr>
+            </a:gs>
+            <a:gs pos="100000">
+              <a:schemeClr val="phClr">
+                <a:shade val="63000"/>
+                <a:satMod val="120000"/>
+              </a:schemeClr>
+            </a:gs>
+          </a:gsLst>
+          <a:lin ang="5400000" scaled="0"/>
+        </a:gradFill>
+      </a:bgFillStyleLst>
+    </a:fmtScheme>
+  </a:themeElements>
+  <a:objectDefaults/>
+  <a:extraClrSchemeLst/>
+  <a:extLst>
+    <a:ext uri="{05A4C25C-085E-4340-85A3-A5531E510DB2}">
+      <thm15:themeFamily xmlns:thm15="http://schemas.microsoft.com/office/thememl/2012/main" name="Office Theme" id="{62F939B6-93AF-4DB8-9C6B-D6C7DFDC589F}" vid="{4A3C46E8-61CC-4603-A589-7422A47A8E4A}"/>
+    </a:ext>
+  </a:extLst>
+</a:theme>
 </file>
</xml_diff>